<commit_message>
Präsentation: Akzentfarbe auf #E8963C umstellen
Co-Authored-By: Claude Opus 5.5 <noreply@anthropic.com>
Claude-Session: https://claude.ai/code/session_01Azv4xVHS22bDY7j2oUgLPs
</commit_message>
<xml_diff>
--- a/praesentationen/mindset_mentale_staerke/Mindset_und_mentale_Staerke.pptx
+++ b/praesentationen/mindset_mentale_staerke/Mindset_und_mentale_Staerke.pptx
@@ -3233,7 +3233,7 @@
             <a:lvl1pPr>
               <a:defRPr sz="900">
                 <a:solidFill>
-                  <a:srgbClr val="CC9933"/>
+                  <a:srgbClr val="E8963C"/>
                 </a:solidFill>
                 <a:latin typeface="Arial"/>
                 <a:ea typeface="Arial"/>
@@ -3306,7 +3306,7 @@
             <a:lvl1pPr>
               <a:defRPr sz="900">
                 <a:solidFill>
-                  <a:srgbClr val="CC9933"/>
+                  <a:srgbClr val="E8963C"/>
                 </a:solidFill>
                 <a:latin typeface="Arial"/>
                 <a:ea typeface="Arial"/>
@@ -3629,7 +3629,7 @@
             <a:r>
               <a:rPr lang="en-US" sz="1300" b="1" spc="400" kern="0" dirty="0">
                 <a:solidFill>
-                  <a:srgbClr val="CC9933"/>
+                  <a:srgbClr val="E8963C"/>
                 </a:solidFill>
                 <a:latin typeface="Arial" pitchFamily="34" charset="0"/>
                 <a:ea typeface="Arial" pitchFamily="34" charset="-122"/>
@@ -3724,7 +3724,7 @@
             <a:r>
               <a:rPr lang="en-US" sz="1800" dirty="0">
                 <a:solidFill>
-                  <a:srgbClr val="CC9933"/>
+                  <a:srgbClr val="E8963C"/>
                 </a:solidFill>
                 <a:latin typeface="Arial" pitchFamily="34" charset="0"/>
                 <a:ea typeface="Arial" pitchFamily="34" charset="-122"/>
@@ -3751,11 +3751,11 @@
             <a:avLst/>
           </a:prstGeom>
           <a:solidFill>
-            <a:srgbClr val="CC9933"/>
+            <a:srgbClr val="E8963C"/>
           </a:solidFill>
           <a:ln w="12700">
             <a:solidFill>
-              <a:srgbClr val="CC9933"/>
+              <a:srgbClr val="E8963C"/>
             </a:solidFill>
             <a:prstDash val="solid"/>
           </a:ln>
@@ -3815,7 +3815,7 @@
             <a:lvl1pPr>
               <a:defRPr sz="900">
                 <a:solidFill>
-                  <a:srgbClr val="CC9933"/>
+                  <a:srgbClr val="E8963C"/>
                 </a:solidFill>
                 <a:latin typeface="Arial"/>
                 <a:ea typeface="Arial"/>
@@ -3885,7 +3885,7 @@
             <a:r>
               <a:rPr lang="en-US" sz="11000" b="1" dirty="0">
                 <a:solidFill>
-                  <a:srgbClr val="CC9933"/>
+                  <a:srgbClr val="E8963C"/>
                 </a:solidFill>
                 <a:latin typeface="Arial" pitchFamily="34" charset="0"/>
                 <a:ea typeface="Arial" pitchFamily="34" charset="-122"/>
@@ -3963,7 +3963,7 @@
             <a:r>
               <a:rPr lang="en-US" sz="1500" dirty="0">
                 <a:solidFill>
-                  <a:srgbClr val="CC9933"/>
+                  <a:srgbClr val="E8963C"/>
                 </a:solidFill>
                 <a:latin typeface="Arial" pitchFamily="34" charset="0"/>
                 <a:ea typeface="Arial" pitchFamily="34" charset="-122"/>
@@ -4005,7 +4005,7 @@
             <a:lvl1pPr>
               <a:defRPr sz="900">
                 <a:solidFill>
-                  <a:srgbClr val="CC9933"/>
+                  <a:srgbClr val="E8963C"/>
                 </a:solidFill>
                 <a:latin typeface="Arial"/>
                 <a:ea typeface="Arial"/>
@@ -4075,7 +4075,7 @@
             <a:r>
               <a:rPr lang="en-US" sz="8800" b="1" dirty="0">
                 <a:solidFill>
-                  <a:srgbClr val="CC9933"/>
+                  <a:srgbClr val="E8963C"/>
                 </a:solidFill>
                 <a:latin typeface="Arial" pitchFamily="34" charset="0"/>
                 <a:ea typeface="Arial" pitchFamily="34" charset="-122"/>
@@ -4153,7 +4153,7 @@
             <a:r>
               <a:rPr lang="en-US" sz="1600" i="1" dirty="0">
                 <a:solidFill>
-                  <a:srgbClr val="CC9933"/>
+                  <a:srgbClr val="E8963C"/>
                 </a:solidFill>
                 <a:latin typeface="Arial" pitchFamily="34" charset="0"/>
                 <a:ea typeface="Arial" pitchFamily="34" charset="-122"/>
@@ -4180,11 +4180,11 @@
             <a:avLst/>
           </a:prstGeom>
           <a:solidFill>
-            <a:srgbClr val="CC9933"/>
+            <a:srgbClr val="E8963C"/>
           </a:solidFill>
           <a:ln w="12700">
             <a:solidFill>
-              <a:srgbClr val="CC9933"/>
+              <a:srgbClr val="E8963C"/>
             </a:solidFill>
             <a:prstDash val="solid"/>
           </a:ln>
@@ -4244,7 +4244,7 @@
             <a:lvl1pPr>
               <a:defRPr sz="900">
                 <a:solidFill>
-                  <a:srgbClr val="CC9933"/>
+                  <a:srgbClr val="E8963C"/>
                 </a:solidFill>
                 <a:latin typeface="Arial"/>
                 <a:ea typeface="Arial"/>
@@ -4314,7 +4314,7 @@
             <a:r>
               <a:rPr lang="en-US" sz="3000" b="1" dirty="0">
                 <a:solidFill>
-                  <a:srgbClr val="CC9933"/>
+                  <a:srgbClr val="E8963C"/>
                 </a:solidFill>
                 <a:latin typeface="Arial" pitchFamily="34" charset="0"/>
                 <a:ea typeface="Arial" pitchFamily="34" charset="-122"/>
@@ -4380,7 +4380,7 @@
             <a:r>
               <a:rPr lang="en-US" sz="5400" b="1" dirty="0">
                 <a:solidFill>
-                  <a:srgbClr val="CC9933"/>
+                  <a:srgbClr val="E8963C"/>
                 </a:solidFill>
                 <a:latin typeface="Arial" pitchFamily="34" charset="0"/>
                 <a:ea typeface="Arial" pitchFamily="34" charset="-122"/>
@@ -4491,7 +4491,7 @@
           </a:solidFill>
           <a:ln w="15875">
             <a:solidFill>
-              <a:srgbClr val="CC9933"/>
+              <a:srgbClr val="E8963C"/>
             </a:solidFill>
             <a:prstDash val="solid"/>
           </a:ln>
@@ -4524,7 +4524,7 @@
             <a:r>
               <a:rPr lang="en-US" sz="5400" b="1" dirty="0">
                 <a:solidFill>
-                  <a:srgbClr val="CC9933"/>
+                  <a:srgbClr val="E8963C"/>
                 </a:solidFill>
                 <a:latin typeface="Arial" pitchFamily="34" charset="0"/>
                 <a:ea typeface="Arial" pitchFamily="34" charset="-122"/>
@@ -4668,7 +4668,7 @@
             <a:r>
               <a:rPr lang="en-US" sz="5400" b="1" dirty="0">
                 <a:solidFill>
-                  <a:srgbClr val="CC9933"/>
+                  <a:srgbClr val="E8963C"/>
                 </a:solidFill>
                 <a:latin typeface="Arial" pitchFamily="34" charset="0"/>
                 <a:ea typeface="Arial" pitchFamily="34" charset="-122"/>
@@ -4785,7 +4785,7 @@
             <a:r>
               <a:rPr lang="en-US" sz="1600" b="1" dirty="0">
                 <a:solidFill>
-                  <a:srgbClr val="CC9933"/>
+                  <a:srgbClr val="E8963C"/>
                 </a:solidFill>
                 <a:latin typeface="Arial" pitchFamily="34" charset="0"/>
                 <a:ea typeface="Arial" pitchFamily="34" charset="-122"/>
@@ -4827,7 +4827,7 @@
             <a:lvl1pPr>
               <a:defRPr sz="900">
                 <a:solidFill>
-                  <a:srgbClr val="CC9933"/>
+                  <a:srgbClr val="E8963C"/>
                 </a:solidFill>
                 <a:latin typeface="Arial"/>
                 <a:ea typeface="Arial"/>
@@ -4897,7 +4897,7 @@
             <a:r>
               <a:rPr lang="en-US" sz="3000" b="1" dirty="0">
                 <a:solidFill>
-                  <a:srgbClr val="CC9933"/>
+                  <a:srgbClr val="E8963C"/>
                 </a:solidFill>
                 <a:latin typeface="Arial" pitchFamily="34" charset="0"/>
                 <a:ea typeface="Arial" pitchFamily="34" charset="-122"/>
@@ -4926,11 +4926,11 @@
             </a:avLst>
           </a:prstGeom>
           <a:solidFill>
-            <a:srgbClr val="CC9933"/>
+            <a:srgbClr val="E8963C"/>
           </a:solidFill>
           <a:ln w="12700">
             <a:solidFill>
-              <a:srgbClr val="CC9933"/>
+              <a:srgbClr val="E8963C"/>
             </a:solidFill>
             <a:prstDash val="solid"/>
           </a:ln>
@@ -4990,11 +4990,11 @@
             <a:avLst/>
           </a:prstGeom>
           <a:solidFill>
-            <a:srgbClr val="CC9933"/>
+            <a:srgbClr val="E8963C"/>
           </a:solidFill>
           <a:ln w="12700">
             <a:solidFill>
-              <a:srgbClr val="CC9933"/>
+              <a:srgbClr val="E8963C"/>
             </a:solidFill>
             <a:prstDash val="solid"/>
           </a:ln>
@@ -5066,7 +5066,7 @@
             <a:r>
               <a:rPr lang="en-US" sz="1400" b="1" dirty="0">
                 <a:solidFill>
-                  <a:srgbClr val="CC9933"/>
+                  <a:srgbClr val="E8963C"/>
                 </a:solidFill>
                 <a:latin typeface="Arial" pitchFamily="34" charset="0"/>
                 <a:ea typeface="Arial" pitchFamily="34" charset="-122"/>
@@ -5132,11 +5132,11 @@
             <a:avLst/>
           </a:prstGeom>
           <a:solidFill>
-            <a:srgbClr val="CC9933"/>
+            <a:srgbClr val="E8963C"/>
           </a:solidFill>
           <a:ln w="12700">
             <a:solidFill>
-              <a:srgbClr val="CC9933"/>
+              <a:srgbClr val="E8963C"/>
             </a:solidFill>
             <a:prstDash val="solid"/>
           </a:ln>
@@ -5208,7 +5208,7 @@
             <a:r>
               <a:rPr lang="en-US" sz="1400" b="1" dirty="0">
                 <a:solidFill>
-                  <a:srgbClr val="CC9933"/>
+                  <a:srgbClr val="E8963C"/>
                 </a:solidFill>
                 <a:latin typeface="Arial" pitchFamily="34" charset="0"/>
                 <a:ea typeface="Arial" pitchFamily="34" charset="-122"/>
@@ -5274,11 +5274,11 @@
             <a:avLst/>
           </a:prstGeom>
           <a:solidFill>
-            <a:srgbClr val="CC9933"/>
+            <a:srgbClr val="E8963C"/>
           </a:solidFill>
           <a:ln w="12700">
             <a:solidFill>
-              <a:srgbClr val="CC9933"/>
+              <a:srgbClr val="E8963C"/>
             </a:solidFill>
             <a:prstDash val="solid"/>
           </a:ln>
@@ -5350,7 +5350,7 @@
             <a:r>
               <a:rPr lang="en-US" sz="1400" b="1" dirty="0">
                 <a:solidFill>
-                  <a:srgbClr val="CC9933"/>
+                  <a:srgbClr val="E8963C"/>
                 </a:solidFill>
                 <a:latin typeface="Arial" pitchFamily="34" charset="0"/>
                 <a:ea typeface="Arial" pitchFamily="34" charset="-122"/>
@@ -5416,11 +5416,11 @@
             <a:avLst/>
           </a:prstGeom>
           <a:solidFill>
-            <a:srgbClr val="CC9933"/>
+            <a:srgbClr val="E8963C"/>
           </a:solidFill>
           <a:ln w="12700">
             <a:solidFill>
-              <a:srgbClr val="CC9933"/>
+              <a:srgbClr val="E8963C"/>
             </a:solidFill>
             <a:prstDash val="solid"/>
           </a:ln>
@@ -5492,7 +5492,7 @@
             <a:r>
               <a:rPr lang="en-US" sz="1400" b="1" dirty="0">
                 <a:solidFill>
-                  <a:srgbClr val="CC9933"/>
+                  <a:srgbClr val="E8963C"/>
                 </a:solidFill>
                 <a:latin typeface="Arial" pitchFamily="34" charset="0"/>
                 <a:ea typeface="Arial" pitchFamily="34" charset="-122"/>
@@ -5564,7 +5564,7 @@
           </a:solidFill>
           <a:ln w="15875">
             <a:solidFill>
-              <a:srgbClr val="CC9933"/>
+              <a:srgbClr val="E8963C"/>
             </a:solidFill>
             <a:prstDash val="solid"/>
           </a:ln>
@@ -5585,11 +5585,11 @@
             <a:avLst/>
           </a:prstGeom>
           <a:solidFill>
-            <a:srgbClr val="CC9933"/>
+            <a:srgbClr val="E8963C"/>
           </a:solidFill>
           <a:ln w="12700">
             <a:solidFill>
-              <a:srgbClr val="CC9933"/>
+              <a:srgbClr val="E8963C"/>
             </a:solidFill>
             <a:prstDash val="solid"/>
           </a:ln>
@@ -5646,7 +5646,7 @@
             <a:r>
               <a:rPr lang="en-US" sz="1400" b="1" dirty="0">
                 <a:solidFill>
-                  <a:srgbClr val="CC9933"/>
+                  <a:srgbClr val="E8963C"/>
                 </a:solidFill>
                 <a:latin typeface="Arial" pitchFamily="34" charset="0"/>
                 <a:ea typeface="Arial" pitchFamily="34" charset="-122"/>
@@ -5727,7 +5727,7 @@
             <a:lvl1pPr>
               <a:defRPr sz="900">
                 <a:solidFill>
-                  <a:srgbClr val="CC9933"/>
+                  <a:srgbClr val="E8963C"/>
                 </a:solidFill>
                 <a:latin typeface="Arial"/>
                 <a:ea typeface="Arial"/>
@@ -5797,7 +5797,7 @@
             <a:r>
               <a:rPr lang="en-US" sz="3000" b="1" dirty="0">
                 <a:solidFill>
-                  <a:srgbClr val="CC9933"/>
+                  <a:srgbClr val="E8963C"/>
                 </a:solidFill>
                 <a:latin typeface="Arial" pitchFamily="34" charset="0"/>
                 <a:ea typeface="Arial" pitchFamily="34" charset="-122"/>
@@ -5863,11 +5863,11 @@
             <a:avLst/>
           </a:prstGeom>
           <a:solidFill>
-            <a:srgbClr val="CC9933"/>
+            <a:srgbClr val="E8963C"/>
           </a:solidFill>
           <a:ln w="12700">
             <a:solidFill>
-              <a:srgbClr val="CC9933"/>
+              <a:srgbClr val="E8963C"/>
             </a:solidFill>
             <a:prstDash val="solid"/>
           </a:ln>
@@ -5924,7 +5924,7 @@
             <a:r>
               <a:rPr lang="en-US" sz="1500" b="1" dirty="0">
                 <a:solidFill>
-                  <a:srgbClr val="CC9933"/>
+                  <a:srgbClr val="E8963C"/>
                 </a:solidFill>
                 <a:latin typeface="Arial" pitchFamily="34" charset="0"/>
                 <a:ea typeface="Arial" pitchFamily="34" charset="-122"/>
@@ -5990,11 +5990,11 @@
             <a:avLst/>
           </a:prstGeom>
           <a:solidFill>
-            <a:srgbClr val="CC9933"/>
+            <a:srgbClr val="E8963C"/>
           </a:solidFill>
           <a:ln w="12700">
             <a:solidFill>
-              <a:srgbClr val="CC9933"/>
+              <a:srgbClr val="E8963C"/>
             </a:solidFill>
             <a:prstDash val="solid"/>
           </a:ln>
@@ -6051,7 +6051,7 @@
             <a:r>
               <a:rPr lang="en-US" sz="1500" b="1" dirty="0">
                 <a:solidFill>
-                  <a:srgbClr val="CC9933"/>
+                  <a:srgbClr val="E8963C"/>
                 </a:solidFill>
                 <a:latin typeface="Arial" pitchFamily="34" charset="0"/>
                 <a:ea typeface="Arial" pitchFamily="34" charset="-122"/>
@@ -6117,11 +6117,11 @@
             <a:avLst/>
           </a:prstGeom>
           <a:solidFill>
-            <a:srgbClr val="CC9933"/>
+            <a:srgbClr val="E8963C"/>
           </a:solidFill>
           <a:ln w="12700">
             <a:solidFill>
-              <a:srgbClr val="CC9933"/>
+              <a:srgbClr val="E8963C"/>
             </a:solidFill>
             <a:prstDash val="solid"/>
           </a:ln>
@@ -6178,7 +6178,7 @@
             <a:r>
               <a:rPr lang="en-US" sz="1500" b="1" dirty="0">
                 <a:solidFill>
-                  <a:srgbClr val="CC9933"/>
+                  <a:srgbClr val="E8963C"/>
                 </a:solidFill>
                 <a:latin typeface="Arial" pitchFamily="34" charset="0"/>
                 <a:ea typeface="Arial" pitchFamily="34" charset="-122"/>
@@ -6244,11 +6244,11 @@
             <a:avLst/>
           </a:prstGeom>
           <a:solidFill>
-            <a:srgbClr val="CC9933"/>
+            <a:srgbClr val="E8963C"/>
           </a:solidFill>
           <a:ln w="12700">
             <a:solidFill>
-              <a:srgbClr val="CC9933"/>
+              <a:srgbClr val="E8963C"/>
             </a:solidFill>
             <a:prstDash val="solid"/>
           </a:ln>
@@ -6305,7 +6305,7 @@
             <a:r>
               <a:rPr lang="en-US" sz="1500" b="1" dirty="0">
                 <a:solidFill>
-                  <a:srgbClr val="CC9933"/>
+                  <a:srgbClr val="E8963C"/>
                 </a:solidFill>
                 <a:latin typeface="Arial" pitchFamily="34" charset="0"/>
                 <a:ea typeface="Arial" pitchFamily="34" charset="-122"/>
@@ -6377,7 +6377,7 @@
           </a:solidFill>
           <a:ln w="15875">
             <a:solidFill>
-              <a:srgbClr val="CC9933"/>
+              <a:srgbClr val="E8963C"/>
             </a:solidFill>
             <a:prstDash val="solid"/>
           </a:ln>
@@ -6410,7 +6410,7 @@
             <a:r>
               <a:rPr lang="en-US" sz="1400" b="1" dirty="0">
                 <a:solidFill>
-                  <a:srgbClr val="CC9933"/>
+                  <a:srgbClr val="E8963C"/>
                 </a:solidFill>
                 <a:latin typeface="Arial" pitchFamily="34" charset="0"/>
                 <a:ea typeface="Arial" pitchFamily="34" charset="-122"/>
@@ -6491,7 +6491,7 @@
             <a:lvl1pPr>
               <a:defRPr sz="900">
                 <a:solidFill>
-                  <a:srgbClr val="CC9933"/>
+                  <a:srgbClr val="E8963C"/>
                 </a:solidFill>
                 <a:latin typeface="Arial"/>
                 <a:ea typeface="Arial"/>
@@ -6561,7 +6561,7 @@
             <a:r>
               <a:rPr lang="en-US" sz="3000" b="1" dirty="0">
                 <a:solidFill>
-                  <a:srgbClr val="CC9933"/>
+                  <a:srgbClr val="E8963C"/>
                 </a:solidFill>
                 <a:latin typeface="Arial" pitchFamily="34" charset="0"/>
                 <a:ea typeface="Arial" pitchFamily="34" charset="-122"/>
@@ -6590,11 +6590,11 @@
             </a:avLst>
           </a:prstGeom>
           <a:solidFill>
-            <a:srgbClr val="CC9933"/>
+            <a:srgbClr val="E8963C"/>
           </a:solidFill>
           <a:ln w="12700">
             <a:solidFill>
-              <a:srgbClr val="CC9933"/>
+              <a:srgbClr val="E8963C"/>
             </a:solidFill>
             <a:prstDash val="solid"/>
           </a:ln>
@@ -6732,7 +6732,7 @@
             <a:r>
               <a:rPr lang="en-US" sz="1500" b="1" dirty="0">
                 <a:solidFill>
-                  <a:srgbClr val="CC9933"/>
+                  <a:srgbClr val="E8963C"/>
                 </a:solidFill>
                 <a:latin typeface="Arial" pitchFamily="34" charset="0"/>
                 <a:ea typeface="Arial" pitchFamily="34" charset="-122"/>
@@ -6854,7 +6854,7 @@
             <a:r>
               <a:rPr lang="en-US" sz="1500" b="1" dirty="0">
                 <a:solidFill>
-                  <a:srgbClr val="CC9933"/>
+                  <a:srgbClr val="E8963C"/>
                 </a:solidFill>
                 <a:latin typeface="Arial" pitchFamily="34" charset="0"/>
                 <a:ea typeface="Arial" pitchFamily="34" charset="-122"/>
@@ -6976,7 +6976,7 @@
             <a:r>
               <a:rPr lang="en-US" sz="1500" b="1" dirty="0">
                 <a:solidFill>
-                  <a:srgbClr val="CC9933"/>
+                  <a:srgbClr val="E8963C"/>
                 </a:solidFill>
                 <a:latin typeface="Arial" pitchFamily="34" charset="0"/>
                 <a:ea typeface="Arial" pitchFamily="34" charset="-122"/>
@@ -7098,7 +7098,7 @@
             <a:r>
               <a:rPr lang="en-US" sz="1500" b="1" dirty="0">
                 <a:solidFill>
-                  <a:srgbClr val="CC9933"/>
+                  <a:srgbClr val="E8963C"/>
                 </a:solidFill>
                 <a:latin typeface="Arial" pitchFamily="34" charset="0"/>
                 <a:ea typeface="Arial" pitchFamily="34" charset="-122"/>
@@ -7193,7 +7193,7 @@
             <a:r>
               <a:rPr lang="en-US" sz="1500" b="1" dirty="0">
                 <a:solidFill>
-                  <a:srgbClr val="CC9933"/>
+                  <a:srgbClr val="E8963C"/>
                 </a:solidFill>
                 <a:latin typeface="Arial" pitchFamily="34" charset="0"/>
                 <a:ea typeface="Arial" pitchFamily="34" charset="-122"/>
@@ -7249,7 +7249,7 @@
             <a:lvl1pPr>
               <a:defRPr sz="900">
                 <a:solidFill>
-                  <a:srgbClr val="CC9933"/>
+                  <a:srgbClr val="E8963C"/>
                 </a:solidFill>
                 <a:latin typeface="Arial"/>
                 <a:ea typeface="Arial"/>
@@ -7319,7 +7319,7 @@
             <a:r>
               <a:rPr lang="en-US" sz="8800" b="1" dirty="0">
                 <a:solidFill>
-                  <a:srgbClr val="CC9933"/>
+                  <a:srgbClr val="E8963C"/>
                 </a:solidFill>
                 <a:latin typeface="Arial" pitchFamily="34" charset="0"/>
                 <a:ea typeface="Arial" pitchFamily="34" charset="-122"/>
@@ -7397,7 +7397,7 @@
             <a:r>
               <a:rPr lang="en-US" sz="1600" i="1" dirty="0">
                 <a:solidFill>
-                  <a:srgbClr val="CC9933"/>
+                  <a:srgbClr val="E8963C"/>
                 </a:solidFill>
                 <a:latin typeface="Arial" pitchFamily="34" charset="0"/>
                 <a:ea typeface="Arial" pitchFamily="34" charset="-122"/>
@@ -7424,11 +7424,11 @@
             <a:avLst/>
           </a:prstGeom>
           <a:solidFill>
-            <a:srgbClr val="CC9933"/>
+            <a:srgbClr val="E8963C"/>
           </a:solidFill>
           <a:ln w="12700">
             <a:solidFill>
-              <a:srgbClr val="CC9933"/>
+              <a:srgbClr val="E8963C"/>
             </a:solidFill>
             <a:prstDash val="solid"/>
           </a:ln>
@@ -7488,7 +7488,7 @@
             <a:lvl1pPr>
               <a:defRPr sz="900">
                 <a:solidFill>
-                  <a:srgbClr val="CC9933"/>
+                  <a:srgbClr val="E8963C"/>
                 </a:solidFill>
                 <a:latin typeface="Arial"/>
                 <a:ea typeface="Arial"/>
@@ -7558,7 +7558,7 @@
             <a:r>
               <a:rPr lang="en-US" sz="3000" b="1" dirty="0">
                 <a:solidFill>
-                  <a:srgbClr val="CC9933"/>
+                  <a:srgbClr val="E8963C"/>
                 </a:solidFill>
                 <a:latin typeface="Arial" pitchFamily="34" charset="0"/>
                 <a:ea typeface="Arial" pitchFamily="34" charset="-122"/>
@@ -7587,11 +7587,11 @@
             </a:avLst>
           </a:prstGeom>
           <a:solidFill>
-            <a:srgbClr val="CC9933"/>
+            <a:srgbClr val="E8963C"/>
           </a:solidFill>
           <a:ln w="12700">
             <a:solidFill>
-              <a:srgbClr val="CC9933"/>
+              <a:srgbClr val="E8963C"/>
             </a:solidFill>
             <a:prstDash val="solid"/>
           </a:ln>
@@ -7655,7 +7655,7 @@
           </a:solidFill>
           <a:ln w="38100">
             <a:solidFill>
-              <a:srgbClr val="CC9933"/>
+              <a:srgbClr val="E8963C"/>
             </a:solidFill>
             <a:prstDash val="solid"/>
           </a:ln>
@@ -7900,11 +7900,11 @@
             <a:avLst/>
           </a:prstGeom>
           <a:solidFill>
-            <a:srgbClr val="CC9933"/>
+            <a:srgbClr val="E8963C"/>
           </a:solidFill>
           <a:ln w="12700">
             <a:solidFill>
-              <a:srgbClr val="CC9933"/>
+              <a:srgbClr val="E8963C"/>
             </a:solidFill>
             <a:prstDash val="solid"/>
           </a:ln>
@@ -7949,11 +7949,11 @@
             <a:avLst/>
           </a:prstGeom>
           <a:solidFill>
-            <a:srgbClr val="CC9933"/>
+            <a:srgbClr val="E8963C"/>
           </a:solidFill>
           <a:ln w="12700">
             <a:solidFill>
-              <a:srgbClr val="CC9933"/>
+              <a:srgbClr val="E8963C"/>
             </a:solidFill>
             <a:prstDash val="solid"/>
           </a:ln>
@@ -8025,7 +8025,7 @@
             <a:r>
               <a:rPr lang="en-US" sz="1400" b="1" dirty="0">
                 <a:solidFill>
-                  <a:srgbClr val="CC9933"/>
+                  <a:srgbClr val="E8963C"/>
                 </a:solidFill>
                 <a:latin typeface="Arial" pitchFamily="34" charset="0"/>
                 <a:ea typeface="Arial" pitchFamily="34" charset="-122"/>
@@ -8091,11 +8091,11 @@
             <a:avLst/>
           </a:prstGeom>
           <a:solidFill>
-            <a:srgbClr val="CC9933"/>
+            <a:srgbClr val="E8963C"/>
           </a:solidFill>
           <a:ln w="12700">
             <a:solidFill>
-              <a:srgbClr val="CC9933"/>
+              <a:srgbClr val="E8963C"/>
             </a:solidFill>
             <a:prstDash val="solid"/>
           </a:ln>
@@ -8167,7 +8167,7 @@
             <a:r>
               <a:rPr lang="en-US" sz="1400" b="1" dirty="0">
                 <a:solidFill>
-                  <a:srgbClr val="CC9933"/>
+                  <a:srgbClr val="E8963C"/>
                 </a:solidFill>
                 <a:latin typeface="Arial" pitchFamily="34" charset="0"/>
                 <a:ea typeface="Arial" pitchFamily="34" charset="-122"/>
@@ -8233,11 +8233,11 @@
             <a:avLst/>
           </a:prstGeom>
           <a:solidFill>
-            <a:srgbClr val="CC9933"/>
+            <a:srgbClr val="E8963C"/>
           </a:solidFill>
           <a:ln w="12700">
             <a:solidFill>
-              <a:srgbClr val="CC9933"/>
+              <a:srgbClr val="E8963C"/>
             </a:solidFill>
             <a:prstDash val="solid"/>
           </a:ln>
@@ -8309,7 +8309,7 @@
             <a:r>
               <a:rPr lang="en-US" sz="1400" b="1" dirty="0">
                 <a:solidFill>
-                  <a:srgbClr val="CC9933"/>
+                  <a:srgbClr val="E8963C"/>
                 </a:solidFill>
                 <a:latin typeface="Arial" pitchFamily="34" charset="0"/>
                 <a:ea typeface="Arial" pitchFamily="34" charset="-122"/>
@@ -8375,11 +8375,11 @@
             <a:avLst/>
           </a:prstGeom>
           <a:solidFill>
-            <a:srgbClr val="CC9933"/>
+            <a:srgbClr val="E8963C"/>
           </a:solidFill>
           <a:ln w="12700">
             <a:solidFill>
-              <a:srgbClr val="CC9933"/>
+              <a:srgbClr val="E8963C"/>
             </a:solidFill>
             <a:prstDash val="solid"/>
           </a:ln>
@@ -8451,7 +8451,7 @@
             <a:r>
               <a:rPr lang="en-US" sz="1400" b="1" dirty="0">
                 <a:solidFill>
-                  <a:srgbClr val="CC9933"/>
+                  <a:srgbClr val="E8963C"/>
                 </a:solidFill>
                 <a:latin typeface="Arial" pitchFamily="34" charset="0"/>
                 <a:ea typeface="Arial" pitchFamily="34" charset="-122"/>
@@ -8532,7 +8532,7 @@
             <a:lvl1pPr>
               <a:defRPr sz="900">
                 <a:solidFill>
-                  <a:srgbClr val="CC9933"/>
+                  <a:srgbClr val="E8963C"/>
                 </a:solidFill>
                 <a:latin typeface="Arial"/>
                 <a:ea typeface="Arial"/>
@@ -8602,7 +8602,7 @@
             <a:r>
               <a:rPr lang="en-US" sz="3000" b="1" dirty="0">
                 <a:solidFill>
-                  <a:srgbClr val="CC9933"/>
+                  <a:srgbClr val="E8963C"/>
                 </a:solidFill>
                 <a:latin typeface="Arial" pitchFamily="34" charset="0"/>
                 <a:ea typeface="Arial" pitchFamily="34" charset="-122"/>
@@ -8707,7 +8707,7 @@
             <a:r>
               <a:rPr lang="en-US" sz="2600" b="1" dirty="0">
                 <a:solidFill>
-                  <a:srgbClr val="CC9933"/>
+                  <a:srgbClr val="E8963C"/>
                 </a:solidFill>
                 <a:latin typeface="Arial" pitchFamily="34" charset="0"/>
                 <a:ea typeface="Arial" pitchFamily="34" charset="-122"/>
@@ -8740,7 +8740,7 @@
           </a:solidFill>
           <a:ln w="15875">
             <a:solidFill>
-              <a:srgbClr val="CC9933"/>
+              <a:srgbClr val="E8963C"/>
             </a:solidFill>
             <a:prstDash val="solid"/>
           </a:ln>
@@ -8773,7 +8773,7 @@
             <a:r>
               <a:rPr lang="en-US" sz="1600" b="1" dirty="0">
                 <a:solidFill>
-                  <a:srgbClr val="CC9933"/>
+                  <a:srgbClr val="E8963C"/>
                 </a:solidFill>
                 <a:latin typeface="Arial" pitchFamily="34" charset="0"/>
                 <a:ea typeface="Arial" pitchFamily="34" charset="-122"/>
@@ -8878,7 +8878,7 @@
             <a:r>
               <a:rPr lang="en-US" sz="2600" b="1" dirty="0">
                 <a:solidFill>
-                  <a:srgbClr val="CC9933"/>
+                  <a:srgbClr val="E8963C"/>
                 </a:solidFill>
                 <a:latin typeface="Arial" pitchFamily="34" charset="0"/>
                 <a:ea typeface="Arial" pitchFamily="34" charset="-122"/>
@@ -8911,7 +8911,7 @@
           </a:solidFill>
           <a:ln w="15875">
             <a:solidFill>
-              <a:srgbClr val="CC9933"/>
+              <a:srgbClr val="E8963C"/>
             </a:solidFill>
             <a:prstDash val="solid"/>
           </a:ln>
@@ -8944,7 +8944,7 @@
             <a:r>
               <a:rPr lang="en-US" sz="1600" b="1" dirty="0">
                 <a:solidFill>
-                  <a:srgbClr val="CC9933"/>
+                  <a:srgbClr val="E8963C"/>
                 </a:solidFill>
                 <a:latin typeface="Arial" pitchFamily="34" charset="0"/>
                 <a:ea typeface="Arial" pitchFamily="34" charset="-122"/>
@@ -9049,7 +9049,7 @@
             <a:r>
               <a:rPr lang="en-US" sz="2600" b="1" dirty="0">
                 <a:solidFill>
-                  <a:srgbClr val="CC9933"/>
+                  <a:srgbClr val="E8963C"/>
                 </a:solidFill>
                 <a:latin typeface="Arial" pitchFamily="34" charset="0"/>
                 <a:ea typeface="Arial" pitchFamily="34" charset="-122"/>
@@ -9082,7 +9082,7 @@
           </a:solidFill>
           <a:ln w="15875">
             <a:solidFill>
-              <a:srgbClr val="CC9933"/>
+              <a:srgbClr val="E8963C"/>
             </a:solidFill>
             <a:prstDash val="solid"/>
           </a:ln>
@@ -9115,7 +9115,7 @@
             <a:r>
               <a:rPr lang="en-US" sz="1600" b="1" dirty="0">
                 <a:solidFill>
-                  <a:srgbClr val="CC9933"/>
+                  <a:srgbClr val="E8963C"/>
                 </a:solidFill>
                 <a:latin typeface="Arial" pitchFamily="34" charset="0"/>
                 <a:ea typeface="Arial" pitchFamily="34" charset="-122"/>
@@ -9196,7 +9196,7 @@
             <a:lvl1pPr>
               <a:defRPr sz="900">
                 <a:solidFill>
-                  <a:srgbClr val="CC9933"/>
+                  <a:srgbClr val="E8963C"/>
                 </a:solidFill>
                 <a:latin typeface="Arial"/>
                 <a:ea typeface="Arial"/>
@@ -9266,7 +9266,7 @@
             <a:r>
               <a:rPr lang="en-US" sz="3000" b="1" dirty="0">
                 <a:solidFill>
-                  <a:srgbClr val="CC9933"/>
+                  <a:srgbClr val="E8963C"/>
                 </a:solidFill>
                 <a:latin typeface="Arial" pitchFamily="34" charset="0"/>
                 <a:ea typeface="Arial" pitchFamily="34" charset="-122"/>
@@ -9295,11 +9295,11 @@
             </a:avLst>
           </a:prstGeom>
           <a:solidFill>
-            <a:srgbClr val="CC9933"/>
+            <a:srgbClr val="E8963C"/>
           </a:solidFill>
           <a:ln w="12700">
             <a:solidFill>
-              <a:srgbClr val="CC9933"/>
+              <a:srgbClr val="E8963C"/>
             </a:solidFill>
             <a:prstDash val="solid"/>
           </a:ln>
@@ -9425,11 +9425,11 @@
             <a:avLst/>
           </a:prstGeom>
           <a:solidFill>
-            <a:srgbClr val="CC9933"/>
+            <a:srgbClr val="E8963C"/>
           </a:solidFill>
           <a:ln w="12700">
             <a:solidFill>
-              <a:srgbClr val="CC9933"/>
+              <a:srgbClr val="E8963C"/>
             </a:solidFill>
             <a:prstDash val="solid"/>
           </a:ln>
@@ -9486,7 +9486,7 @@
             <a:r>
               <a:rPr lang="en-US" sz="1500" b="1" dirty="0">
                 <a:solidFill>
-                  <a:srgbClr val="CC9933"/>
+                  <a:srgbClr val="E8963C"/>
                 </a:solidFill>
                 <a:latin typeface="Arial" pitchFamily="34" charset="0"/>
                 <a:ea typeface="Arial" pitchFamily="34" charset="-122"/>
@@ -9579,11 +9579,11 @@
             <a:avLst/>
           </a:prstGeom>
           <a:solidFill>
-            <a:srgbClr val="CC9933"/>
+            <a:srgbClr val="E8963C"/>
           </a:solidFill>
           <a:ln w="12700">
             <a:solidFill>
-              <a:srgbClr val="CC9933"/>
+              <a:srgbClr val="E8963C"/>
             </a:solidFill>
             <a:prstDash val="solid"/>
           </a:ln>
@@ -9640,7 +9640,7 @@
             <a:r>
               <a:rPr lang="en-US" sz="1500" b="1" dirty="0">
                 <a:solidFill>
-                  <a:srgbClr val="CC9933"/>
+                  <a:srgbClr val="E8963C"/>
                 </a:solidFill>
                 <a:latin typeface="Arial" pitchFamily="34" charset="0"/>
                 <a:ea typeface="Arial" pitchFamily="34" charset="-122"/>
@@ -9733,11 +9733,11 @@
             <a:avLst/>
           </a:prstGeom>
           <a:solidFill>
-            <a:srgbClr val="CC9933"/>
+            <a:srgbClr val="E8963C"/>
           </a:solidFill>
           <a:ln w="12700">
             <a:solidFill>
-              <a:srgbClr val="CC9933"/>
+              <a:srgbClr val="E8963C"/>
             </a:solidFill>
             <a:prstDash val="solid"/>
           </a:ln>
@@ -9794,7 +9794,7 @@
             <a:r>
               <a:rPr lang="en-US" sz="1500" b="1" dirty="0">
                 <a:solidFill>
-                  <a:srgbClr val="CC9933"/>
+                  <a:srgbClr val="E8963C"/>
                 </a:solidFill>
                 <a:latin typeface="Arial" pitchFamily="34" charset="0"/>
                 <a:ea typeface="Arial" pitchFamily="34" charset="-122"/>
@@ -9875,7 +9875,7 @@
             <a:lvl1pPr>
               <a:defRPr sz="900">
                 <a:solidFill>
-                  <a:srgbClr val="CC9933"/>
+                  <a:srgbClr val="E8963C"/>
                 </a:solidFill>
                 <a:latin typeface="Arial"/>
                 <a:ea typeface="Arial"/>
@@ -9945,7 +9945,7 @@
             <a:r>
               <a:rPr lang="en-US" sz="3000" b="1" dirty="0">
                 <a:solidFill>
-                  <a:srgbClr val="CC9933"/>
+                  <a:srgbClr val="E8963C"/>
                 </a:solidFill>
                 <a:latin typeface="Arial" pitchFamily="34" charset="0"/>
                 <a:ea typeface="Arial" pitchFamily="34" charset="-122"/>
@@ -9999,11 +9999,11 @@
             <a:avLst/>
           </a:prstGeom>
           <a:solidFill>
-            <a:srgbClr val="CC9933"/>
+            <a:srgbClr val="E8963C"/>
           </a:solidFill>
           <a:ln w="12700">
             <a:solidFill>
-              <a:srgbClr val="CC9933"/>
+              <a:srgbClr val="E8963C"/>
             </a:solidFill>
             <a:prstDash val="solid"/>
           </a:ln>
@@ -10060,7 +10060,7 @@
             <a:r>
               <a:rPr lang="en-US" sz="1600" b="1" dirty="0">
                 <a:solidFill>
-                  <a:srgbClr val="CC9933"/>
+                  <a:srgbClr val="E8963C"/>
                 </a:solidFill>
                 <a:latin typeface="Arial" pitchFamily="34" charset="0"/>
                 <a:ea typeface="Arial" pitchFamily="34" charset="-122"/>
@@ -10153,11 +10153,11 @@
             <a:avLst/>
           </a:prstGeom>
           <a:solidFill>
-            <a:srgbClr val="CC9933"/>
+            <a:srgbClr val="E8963C"/>
           </a:solidFill>
           <a:ln w="12700">
             <a:solidFill>
-              <a:srgbClr val="CC9933"/>
+              <a:srgbClr val="E8963C"/>
             </a:solidFill>
             <a:prstDash val="solid"/>
           </a:ln>
@@ -10214,7 +10214,7 @@
             <a:r>
               <a:rPr lang="en-US" sz="1600" b="1" dirty="0">
                 <a:solidFill>
-                  <a:srgbClr val="CC9933"/>
+                  <a:srgbClr val="E8963C"/>
                 </a:solidFill>
                 <a:latin typeface="Arial" pitchFamily="34" charset="0"/>
                 <a:ea typeface="Arial" pitchFamily="34" charset="-122"/>
@@ -10307,11 +10307,11 @@
             <a:avLst/>
           </a:prstGeom>
           <a:solidFill>
-            <a:srgbClr val="CC9933"/>
+            <a:srgbClr val="E8963C"/>
           </a:solidFill>
           <a:ln w="12700">
             <a:solidFill>
-              <a:srgbClr val="CC9933"/>
+              <a:srgbClr val="E8963C"/>
             </a:solidFill>
             <a:prstDash val="solid"/>
           </a:ln>
@@ -10368,7 +10368,7 @@
             <a:r>
               <a:rPr lang="en-US" sz="1600" b="1" dirty="0">
                 <a:solidFill>
-                  <a:srgbClr val="CC9933"/>
+                  <a:srgbClr val="E8963C"/>
                 </a:solidFill>
                 <a:latin typeface="Arial" pitchFamily="34" charset="0"/>
                 <a:ea typeface="Arial" pitchFamily="34" charset="-122"/>
@@ -10461,11 +10461,11 @@
             <a:avLst/>
           </a:prstGeom>
           <a:solidFill>
-            <a:srgbClr val="CC9933"/>
+            <a:srgbClr val="E8963C"/>
           </a:solidFill>
           <a:ln w="12700">
             <a:solidFill>
-              <a:srgbClr val="CC9933"/>
+              <a:srgbClr val="E8963C"/>
             </a:solidFill>
             <a:prstDash val="solid"/>
           </a:ln>
@@ -10522,7 +10522,7 @@
             <a:r>
               <a:rPr lang="en-US" sz="1600" b="1" dirty="0">
                 <a:solidFill>
-                  <a:srgbClr val="CC9933"/>
+                  <a:srgbClr val="E8963C"/>
                 </a:solidFill>
                 <a:latin typeface="Arial" pitchFamily="34" charset="0"/>
                 <a:ea typeface="Arial" pitchFamily="34" charset="-122"/>
@@ -10603,7 +10603,7 @@
             <a:lvl1pPr>
               <a:defRPr sz="900">
                 <a:solidFill>
-                  <a:srgbClr val="CC9933"/>
+                  <a:srgbClr val="E8963C"/>
                 </a:solidFill>
                 <a:latin typeface="Arial"/>
                 <a:ea typeface="Arial"/>
@@ -10673,7 +10673,7 @@
             <a:r>
               <a:rPr lang="en-US" sz="3000" b="1" dirty="0">
                 <a:solidFill>
-                  <a:srgbClr val="CC9933"/>
+                  <a:srgbClr val="E8963C"/>
                 </a:solidFill>
                 <a:latin typeface="Arial" pitchFamily="34" charset="0"/>
                 <a:ea typeface="Arial" pitchFamily="34" charset="-122"/>
@@ -10702,11 +10702,11 @@
             </a:avLst>
           </a:prstGeom>
           <a:solidFill>
-            <a:srgbClr val="CC9933"/>
+            <a:srgbClr val="E8963C"/>
           </a:solidFill>
           <a:ln w="12700">
             <a:solidFill>
-              <a:srgbClr val="CC9933"/>
+              <a:srgbClr val="E8963C"/>
             </a:solidFill>
             <a:prstDash val="solid"/>
           </a:ln>
@@ -10894,7 +10894,7 @@
           </a:solidFill>
           <a:ln w="15875">
             <a:solidFill>
-              <a:srgbClr val="CC9933"/>
+              <a:srgbClr val="E8963C"/>
             </a:solidFill>
             <a:prstDash val="solid"/>
           </a:ln>
@@ -10927,7 +10927,7 @@
             <a:r>
               <a:rPr lang="en-US" sz="1600" b="1" dirty="0">
                 <a:solidFill>
-                  <a:srgbClr val="CC9933"/>
+                  <a:srgbClr val="E8963C"/>
                 </a:solidFill>
                 <a:latin typeface="Arial" pitchFamily="34" charset="0"/>
                 <a:ea typeface="Arial" pitchFamily="34" charset="-122"/>
@@ -10966,7 +10966,7 @@
             <a:r>
               <a:rPr lang="en-US" sz="1400" i="1" dirty="0">
                 <a:solidFill>
-                  <a:srgbClr val="CC9933"/>
+                  <a:srgbClr val="E8963C"/>
                 </a:solidFill>
                 <a:latin typeface="Arial" pitchFamily="34" charset="0"/>
                 <a:ea typeface="Arial" pitchFamily="34" charset="-122"/>
@@ -10983,7 +10983,7 @@
             <a:r>
               <a:rPr lang="en-US" sz="1400" i="1" dirty="0">
                 <a:solidFill>
-                  <a:srgbClr val="CC9933"/>
+                  <a:srgbClr val="E8963C"/>
                 </a:solidFill>
                 <a:latin typeface="Arial" pitchFamily="34" charset="0"/>
                 <a:ea typeface="Arial" pitchFamily="34" charset="-122"/>
@@ -11022,7 +11022,7 @@
             <a:r>
               <a:rPr lang="en-US" sz="1400" b="1" dirty="0">
                 <a:solidFill>
-                  <a:srgbClr val="CC9933"/>
+                  <a:srgbClr val="E8963C"/>
                 </a:solidFill>
                 <a:latin typeface="Arial" pitchFamily="34" charset="0"/>
                 <a:ea typeface="Arial" pitchFamily="34" charset="-122"/>
@@ -11078,7 +11078,7 @@
             <a:lvl1pPr>
               <a:defRPr sz="900">
                 <a:solidFill>
-                  <a:srgbClr val="CC9933"/>
+                  <a:srgbClr val="E8963C"/>
                 </a:solidFill>
                 <a:latin typeface="Arial"/>
                 <a:ea typeface="Arial"/>
@@ -11148,7 +11148,7 @@
             <a:r>
               <a:rPr lang="en-US" sz="3000" b="1" dirty="0">
                 <a:solidFill>
-                  <a:srgbClr val="CC9933"/>
+                  <a:srgbClr val="E8963C"/>
                 </a:solidFill>
                 <a:latin typeface="Arial" pitchFamily="34" charset="0"/>
                 <a:ea typeface="Arial" pitchFamily="34" charset="-122"/>
@@ -11200,11 +11200,11 @@
             <a:avLst/>
           </a:prstGeom>
           <a:solidFill>
-            <a:srgbClr val="CC9933"/>
+            <a:srgbClr val="E8963C"/>
           </a:solidFill>
           <a:ln w="12700">
             <a:solidFill>
-              <a:srgbClr val="CC9933"/>
+              <a:srgbClr val="E8963C"/>
             </a:solidFill>
             <a:prstDash val="solid"/>
           </a:ln>
@@ -11332,7 +11332,7 @@
             <a:r>
               <a:rPr lang="en-US" sz="1600" b="1" dirty="0">
                 <a:solidFill>
-                  <a:srgbClr val="CC9933"/>
+                  <a:srgbClr val="E8963C"/>
                 </a:solidFill>
                 <a:latin typeface="Arial" pitchFamily="34" charset="0"/>
                 <a:ea typeface="Arial" pitchFamily="34" charset="-122"/>
@@ -11583,7 +11583,7 @@
             <a:lvl1pPr>
               <a:defRPr sz="900">
                 <a:solidFill>
-                  <a:srgbClr val="CC9933"/>
+                  <a:srgbClr val="E8963C"/>
                 </a:solidFill>
                 <a:latin typeface="Arial"/>
                 <a:ea typeface="Arial"/>
@@ -11653,7 +11653,7 @@
             <a:r>
               <a:rPr lang="en-US" sz="3000" b="1" dirty="0">
                 <a:solidFill>
-                  <a:srgbClr val="CC9933"/>
+                  <a:srgbClr val="E8963C"/>
                 </a:solidFill>
                 <a:latin typeface="Arial" pitchFamily="34" charset="0"/>
                 <a:ea typeface="Arial" pitchFamily="34" charset="-122"/>
@@ -11682,11 +11682,11 @@
             </a:avLst>
           </a:prstGeom>
           <a:solidFill>
-            <a:srgbClr val="CC9933"/>
+            <a:srgbClr val="E8963C"/>
           </a:solidFill>
           <a:ln w="12700">
             <a:solidFill>
-              <a:srgbClr val="CC9933"/>
+              <a:srgbClr val="E8963C"/>
             </a:solidFill>
             <a:prstDash val="solid"/>
           </a:ln>
@@ -11746,11 +11746,11 @@
             <a:avLst/>
           </a:prstGeom>
           <a:solidFill>
-            <a:srgbClr val="CC9933"/>
+            <a:srgbClr val="E8963C"/>
           </a:solidFill>
           <a:ln w="12700">
             <a:solidFill>
-              <a:srgbClr val="CC9933"/>
+              <a:srgbClr val="E8963C"/>
             </a:solidFill>
             <a:prstDash val="solid"/>
           </a:ln>
@@ -11822,7 +11822,7 @@
             <a:r>
               <a:rPr lang="en-US" sz="1400" b="1" dirty="0">
                 <a:solidFill>
-                  <a:srgbClr val="CC9933"/>
+                  <a:srgbClr val="E8963C"/>
                 </a:solidFill>
                 <a:latin typeface="Arial" pitchFamily="34" charset="0"/>
                 <a:ea typeface="Arial" pitchFamily="34" charset="-122"/>
@@ -11888,11 +11888,11 @@
             <a:avLst/>
           </a:prstGeom>
           <a:solidFill>
-            <a:srgbClr val="CC9933"/>
+            <a:srgbClr val="E8963C"/>
           </a:solidFill>
           <a:ln w="12700">
             <a:solidFill>
-              <a:srgbClr val="CC9933"/>
+              <a:srgbClr val="E8963C"/>
             </a:solidFill>
             <a:prstDash val="solid"/>
           </a:ln>
@@ -11964,7 +11964,7 @@
             <a:r>
               <a:rPr lang="en-US" sz="1400" b="1" dirty="0">
                 <a:solidFill>
-                  <a:srgbClr val="CC9933"/>
+                  <a:srgbClr val="E8963C"/>
                 </a:solidFill>
                 <a:latin typeface="Arial" pitchFamily="34" charset="0"/>
                 <a:ea typeface="Arial" pitchFamily="34" charset="-122"/>
@@ -12030,11 +12030,11 @@
             <a:avLst/>
           </a:prstGeom>
           <a:solidFill>
-            <a:srgbClr val="CC9933"/>
+            <a:srgbClr val="E8963C"/>
           </a:solidFill>
           <a:ln w="12700">
             <a:solidFill>
-              <a:srgbClr val="CC9933"/>
+              <a:srgbClr val="E8963C"/>
             </a:solidFill>
             <a:prstDash val="solid"/>
           </a:ln>
@@ -12106,7 +12106,7 @@
             <a:r>
               <a:rPr lang="en-US" sz="1400" b="1" dirty="0">
                 <a:solidFill>
-                  <a:srgbClr val="CC9933"/>
+                  <a:srgbClr val="E8963C"/>
                 </a:solidFill>
                 <a:latin typeface="Arial" pitchFamily="34" charset="0"/>
                 <a:ea typeface="Arial" pitchFamily="34" charset="-122"/>
@@ -12172,11 +12172,11 @@
             <a:avLst/>
           </a:prstGeom>
           <a:solidFill>
-            <a:srgbClr val="CC9933"/>
+            <a:srgbClr val="E8963C"/>
           </a:solidFill>
           <a:ln w="12700">
             <a:solidFill>
-              <a:srgbClr val="CC9933"/>
+              <a:srgbClr val="E8963C"/>
             </a:solidFill>
             <a:prstDash val="solid"/>
           </a:ln>
@@ -12248,7 +12248,7 @@
             <a:r>
               <a:rPr lang="en-US" sz="1400" b="1" dirty="0">
                 <a:solidFill>
-                  <a:srgbClr val="CC9933"/>
+                  <a:srgbClr val="E8963C"/>
                 </a:solidFill>
                 <a:latin typeface="Arial" pitchFamily="34" charset="0"/>
                 <a:ea typeface="Arial" pitchFamily="34" charset="-122"/>
@@ -12320,7 +12320,7 @@
           </a:solidFill>
           <a:ln w="15875">
             <a:solidFill>
-              <a:srgbClr val="CC9933"/>
+              <a:srgbClr val="E8963C"/>
             </a:solidFill>
             <a:prstDash val="solid"/>
           </a:ln>
@@ -12341,11 +12341,11 @@
             <a:avLst/>
           </a:prstGeom>
           <a:solidFill>
-            <a:srgbClr val="CC9933"/>
+            <a:srgbClr val="E8963C"/>
           </a:solidFill>
           <a:ln w="12700">
             <a:solidFill>
-              <a:srgbClr val="CC9933"/>
+              <a:srgbClr val="E8963C"/>
             </a:solidFill>
             <a:prstDash val="solid"/>
           </a:ln>
@@ -12402,7 +12402,7 @@
             <a:r>
               <a:rPr lang="en-US" sz="1400" b="1" dirty="0">
                 <a:solidFill>
-                  <a:srgbClr val="CC9933"/>
+                  <a:srgbClr val="E8963C"/>
                 </a:solidFill>
                 <a:latin typeface="Arial" pitchFamily="34" charset="0"/>
                 <a:ea typeface="Arial" pitchFamily="34" charset="-122"/>
@@ -12483,7 +12483,7 @@
             <a:lvl1pPr>
               <a:defRPr sz="900">
                 <a:solidFill>
-                  <a:srgbClr val="CC9933"/>
+                  <a:srgbClr val="E8963C"/>
                 </a:solidFill>
                 <a:latin typeface="Arial"/>
                 <a:ea typeface="Arial"/>
@@ -12553,7 +12553,7 @@
             <a:r>
               <a:rPr lang="en-US" sz="3000" b="1" dirty="0">
                 <a:solidFill>
-                  <a:srgbClr val="CC9933"/>
+                  <a:srgbClr val="E8963C"/>
                 </a:solidFill>
                 <a:latin typeface="Arial" pitchFamily="34" charset="0"/>
                 <a:ea typeface="Arial" pitchFamily="34" charset="-122"/>
@@ -12621,11 +12621,11 @@
             </a:avLst>
           </a:prstGeom>
           <a:solidFill>
-            <a:srgbClr val="CC9933"/>
+            <a:srgbClr val="E8963C"/>
           </a:solidFill>
           <a:ln w="12700">
             <a:solidFill>
-              <a:srgbClr val="CC9933"/>
+              <a:srgbClr val="E8963C"/>
             </a:solidFill>
             <a:prstDash val="solid"/>
           </a:ln>
@@ -12724,7 +12724,7 @@
             <a:r>
               <a:rPr lang="en-US" sz="4400" b="1" dirty="0">
                 <a:solidFill>
-                  <a:srgbClr val="CC9933"/>
+                  <a:srgbClr val="E8963C"/>
                 </a:solidFill>
                 <a:latin typeface="Arial" pitchFamily="34" charset="0"/>
                 <a:ea typeface="Arial" pitchFamily="34" charset="-122"/>
@@ -12868,7 +12868,7 @@
             <a:r>
               <a:rPr lang="en-US" sz="4400" b="1" dirty="0">
                 <a:solidFill>
-                  <a:srgbClr val="CC9933"/>
+                  <a:srgbClr val="E8963C"/>
                 </a:solidFill>
                 <a:latin typeface="Arial" pitchFamily="34" charset="0"/>
                 <a:ea typeface="Arial" pitchFamily="34" charset="-122"/>
@@ -13012,7 +13012,7 @@
             <a:r>
               <a:rPr lang="en-US" sz="4400" b="1" dirty="0">
                 <a:solidFill>
-                  <a:srgbClr val="CC9933"/>
+                  <a:srgbClr val="E8963C"/>
                 </a:solidFill>
                 <a:latin typeface="Arial" pitchFamily="34" charset="0"/>
                 <a:ea typeface="Arial" pitchFamily="34" charset="-122"/>
@@ -13123,7 +13123,7 @@
           </a:solidFill>
           <a:ln w="15875">
             <a:solidFill>
-              <a:srgbClr val="CC9933"/>
+              <a:srgbClr val="E8963C"/>
             </a:solidFill>
             <a:prstDash val="solid"/>
           </a:ln>
@@ -13156,7 +13156,7 @@
             <a:r>
               <a:rPr lang="en-US" sz="4400" b="1" dirty="0">
                 <a:solidFill>
-                  <a:srgbClr val="CC9933"/>
+                  <a:srgbClr val="E8963C"/>
                 </a:solidFill>
                 <a:latin typeface="Arial" pitchFamily="34" charset="0"/>
                 <a:ea typeface="Arial" pitchFamily="34" charset="-122"/>
@@ -13276,7 +13276,7 @@
             <a:lvl1pPr>
               <a:defRPr sz="900">
                 <a:solidFill>
-                  <a:srgbClr val="CC9933"/>
+                  <a:srgbClr val="E8963C"/>
                 </a:solidFill>
                 <a:latin typeface="Arial"/>
                 <a:ea typeface="Arial"/>
@@ -13346,7 +13346,7 @@
             <a:r>
               <a:rPr lang="en-US" sz="3000" b="1" dirty="0">
                 <a:solidFill>
-                  <a:srgbClr val="CC9933"/>
+                  <a:srgbClr val="E8963C"/>
                 </a:solidFill>
                 <a:latin typeface="Arial" pitchFamily="34" charset="0"/>
                 <a:ea typeface="Arial" pitchFamily="34" charset="-122"/>
@@ -13385,7 +13385,7 @@
             <a:r>
               <a:rPr lang="en-US" sz="15000" b="1" dirty="0">
                 <a:solidFill>
-                  <a:srgbClr val="CC9933"/>
+                  <a:srgbClr val="E8963C"/>
                 </a:solidFill>
                 <a:latin typeface="Arial" pitchFamily="34" charset="0"/>
                 <a:ea typeface="Arial" pitchFamily="34" charset="-122"/>
@@ -13463,7 +13463,7 @@
             <a:r>
               <a:rPr lang="en-US" sz="1400" i="1" dirty="0">
                 <a:solidFill>
-                  <a:srgbClr val="CC9933"/>
+                  <a:srgbClr val="E8963C"/>
                 </a:solidFill>
                 <a:latin typeface="Arial" pitchFamily="34" charset="0"/>
                 <a:ea typeface="Arial" pitchFamily="34" charset="-122"/>
@@ -13490,11 +13490,11 @@
             <a:avLst/>
           </a:prstGeom>
           <a:solidFill>
-            <a:srgbClr val="CC9933"/>
+            <a:srgbClr val="E8963C"/>
           </a:solidFill>
           <a:ln w="12700">
             <a:solidFill>
-              <a:srgbClr val="CC9933"/>
+              <a:srgbClr val="E8963C"/>
             </a:solidFill>
             <a:prstDash val="solid"/>
           </a:ln>
@@ -13566,7 +13566,7 @@
             <a:r>
               <a:rPr lang="en-US" sz="1400" b="1" dirty="0">
                 <a:solidFill>
-                  <a:srgbClr val="CC9933"/>
+                  <a:srgbClr val="E8963C"/>
                 </a:solidFill>
                 <a:latin typeface="Arial" pitchFamily="34" charset="0"/>
                 <a:ea typeface="Arial" pitchFamily="34" charset="-122"/>
@@ -13632,11 +13632,11 @@
             <a:avLst/>
           </a:prstGeom>
           <a:solidFill>
-            <a:srgbClr val="CC9933"/>
+            <a:srgbClr val="E8963C"/>
           </a:solidFill>
           <a:ln w="12700">
             <a:solidFill>
-              <a:srgbClr val="CC9933"/>
+              <a:srgbClr val="E8963C"/>
             </a:solidFill>
             <a:prstDash val="solid"/>
           </a:ln>
@@ -13708,7 +13708,7 @@
             <a:r>
               <a:rPr lang="en-US" sz="1400" b="1" dirty="0">
                 <a:solidFill>
-                  <a:srgbClr val="CC9933"/>
+                  <a:srgbClr val="E8963C"/>
                 </a:solidFill>
                 <a:latin typeface="Arial" pitchFamily="34" charset="0"/>
                 <a:ea typeface="Arial" pitchFamily="34" charset="-122"/>
@@ -13774,11 +13774,11 @@
             <a:avLst/>
           </a:prstGeom>
           <a:solidFill>
-            <a:srgbClr val="CC9933"/>
+            <a:srgbClr val="E8963C"/>
           </a:solidFill>
           <a:ln w="12700">
             <a:solidFill>
-              <a:srgbClr val="CC9933"/>
+              <a:srgbClr val="E8963C"/>
             </a:solidFill>
             <a:prstDash val="solid"/>
           </a:ln>
@@ -13850,7 +13850,7 @@
             <a:r>
               <a:rPr lang="en-US" sz="1400" b="1" dirty="0">
                 <a:solidFill>
-                  <a:srgbClr val="CC9933"/>
+                  <a:srgbClr val="E8963C"/>
                 </a:solidFill>
                 <a:latin typeface="Arial" pitchFamily="34" charset="0"/>
                 <a:ea typeface="Arial" pitchFamily="34" charset="-122"/>
@@ -13931,7 +13931,7 @@
             <a:lvl1pPr>
               <a:defRPr sz="900">
                 <a:solidFill>
-                  <a:srgbClr val="CC9933"/>
+                  <a:srgbClr val="E8963C"/>
                 </a:solidFill>
                 <a:latin typeface="Arial"/>
                 <a:ea typeface="Arial"/>
@@ -14001,7 +14001,7 @@
             <a:r>
               <a:rPr lang="en-US" sz="3000" b="1" dirty="0">
                 <a:solidFill>
-                  <a:srgbClr val="CC9933"/>
+                  <a:srgbClr val="E8963C"/>
                 </a:solidFill>
                 <a:latin typeface="Arial" pitchFamily="34" charset="0"/>
                 <a:ea typeface="Arial" pitchFamily="34" charset="-122"/>
@@ -14106,7 +14106,7 @@
             <a:r>
               <a:rPr lang="en-US" sz="1900" b="1" dirty="0">
                 <a:solidFill>
-                  <a:srgbClr val="CC9933"/>
+                  <a:srgbClr val="E8963C"/>
                 </a:solidFill>
                 <a:latin typeface="Arial" pitchFamily="34" charset="0"/>
                 <a:ea typeface="Arial" pitchFamily="34" charset="-122"/>
@@ -14223,7 +14223,7 @@
             <a:r>
               <a:rPr lang="en-US" sz="1100" b="1" dirty="0">
                 <a:solidFill>
-                  <a:srgbClr val="CC9933"/>
+                  <a:srgbClr val="E8963C"/>
                 </a:solidFill>
                 <a:latin typeface="Arial" pitchFamily="34" charset="0"/>
                 <a:ea typeface="Arial" pitchFamily="34" charset="-122"/>
@@ -14262,7 +14262,7 @@
             <a:r>
               <a:rPr lang="en-US" sz="1300" dirty="0">
                 <a:solidFill>
-                  <a:srgbClr val="CC9933"/>
+                  <a:srgbClr val="E8963C"/>
                 </a:solidFill>
                 <a:latin typeface="Arial" pitchFamily="34" charset="0"/>
                 <a:ea typeface="Arial" pitchFamily="34" charset="-122"/>
@@ -14328,7 +14328,7 @@
             <a:r>
               <a:rPr lang="en-US" sz="1900" b="1" dirty="0">
                 <a:solidFill>
-                  <a:srgbClr val="CC9933"/>
+                  <a:srgbClr val="E8963C"/>
                 </a:solidFill>
                 <a:latin typeface="Arial" pitchFamily="34" charset="0"/>
                 <a:ea typeface="Arial" pitchFamily="34" charset="-122"/>
@@ -14445,7 +14445,7 @@
             <a:r>
               <a:rPr lang="en-US" sz="1100" b="1" dirty="0">
                 <a:solidFill>
-                  <a:srgbClr val="CC9933"/>
+                  <a:srgbClr val="E8963C"/>
                 </a:solidFill>
                 <a:latin typeface="Arial" pitchFamily="34" charset="0"/>
                 <a:ea typeface="Arial" pitchFamily="34" charset="-122"/>
@@ -14484,7 +14484,7 @@
             <a:r>
               <a:rPr lang="en-US" sz="1300" dirty="0">
                 <a:solidFill>
-                  <a:srgbClr val="CC9933"/>
+                  <a:srgbClr val="E8963C"/>
                 </a:solidFill>
                 <a:latin typeface="Arial" pitchFamily="34" charset="0"/>
                 <a:ea typeface="Arial" pitchFamily="34" charset="-122"/>
@@ -14550,7 +14550,7 @@
             <a:r>
               <a:rPr lang="en-US" sz="1900" b="1" dirty="0">
                 <a:solidFill>
-                  <a:srgbClr val="CC9933"/>
+                  <a:srgbClr val="E8963C"/>
                 </a:solidFill>
                 <a:latin typeface="Arial" pitchFamily="34" charset="0"/>
                 <a:ea typeface="Arial" pitchFamily="34" charset="-122"/>
@@ -14667,7 +14667,7 @@
             <a:r>
               <a:rPr lang="en-US" sz="1100" b="1" dirty="0">
                 <a:solidFill>
-                  <a:srgbClr val="CC9933"/>
+                  <a:srgbClr val="E8963C"/>
                 </a:solidFill>
                 <a:latin typeface="Arial" pitchFamily="34" charset="0"/>
                 <a:ea typeface="Arial" pitchFamily="34" charset="-122"/>
@@ -14706,7 +14706,7 @@
             <a:r>
               <a:rPr lang="en-US" sz="1300" dirty="0">
                 <a:solidFill>
-                  <a:srgbClr val="CC9933"/>
+                  <a:srgbClr val="E8963C"/>
                 </a:solidFill>
                 <a:latin typeface="Arial" pitchFamily="34" charset="0"/>
                 <a:ea typeface="Arial" pitchFamily="34" charset="-122"/>
@@ -14748,7 +14748,7 @@
             <a:lvl1pPr>
               <a:defRPr sz="900">
                 <a:solidFill>
-                  <a:srgbClr val="CC9933"/>
+                  <a:srgbClr val="E8963C"/>
                 </a:solidFill>
                 <a:latin typeface="Arial"/>
                 <a:ea typeface="Arial"/>
@@ -14818,7 +14818,7 @@
             <a:r>
               <a:rPr lang="en-US" sz="3000" b="1" dirty="0">
                 <a:solidFill>
-                  <a:srgbClr val="CC9933"/>
+                  <a:srgbClr val="E8963C"/>
                 </a:solidFill>
                 <a:latin typeface="Arial" pitchFamily="34" charset="0"/>
                 <a:ea typeface="Arial" pitchFamily="34" charset="-122"/>
@@ -14847,11 +14847,11 @@
             </a:avLst>
           </a:prstGeom>
           <a:solidFill>
-            <a:srgbClr val="CC9933"/>
+            <a:srgbClr val="E8963C"/>
           </a:solidFill>
           <a:ln w="12700">
             <a:solidFill>
-              <a:srgbClr val="CC9933"/>
+              <a:srgbClr val="E8963C"/>
             </a:solidFill>
             <a:prstDash val="solid"/>
           </a:ln>
@@ -14923,7 +14923,7 @@
             <a:r>
               <a:rPr lang="en-US" sz="1500" i="1" dirty="0">
                 <a:solidFill>
-                  <a:srgbClr val="CC9933"/>
+                  <a:srgbClr val="E8963C"/>
                 </a:solidFill>
                 <a:latin typeface="Arial" pitchFamily="34" charset="0"/>
                 <a:ea typeface="Arial" pitchFamily="34" charset="-122"/>
@@ -14989,7 +14989,7 @@
             <a:r>
               <a:rPr lang="en-US" sz="6000" b="1" dirty="0">
                 <a:solidFill>
-                  <a:srgbClr val="CC9933"/>
+                  <a:srgbClr val="E8963C"/>
                 </a:solidFill>
                 <a:latin typeface="Arial" pitchFamily="34" charset="0"/>
                 <a:ea typeface="Arial" pitchFamily="34" charset="-122"/>
@@ -15094,7 +15094,7 @@
             <a:r>
               <a:rPr lang="en-US" sz="6000" b="1" dirty="0">
                 <a:solidFill>
-                  <a:srgbClr val="CC9933"/>
+                  <a:srgbClr val="E8963C"/>
                 </a:solidFill>
                 <a:latin typeface="Arial" pitchFamily="34" charset="0"/>
                 <a:ea typeface="Arial" pitchFamily="34" charset="-122"/>
@@ -15199,7 +15199,7 @@
             <a:r>
               <a:rPr lang="en-US" sz="6000" b="1" dirty="0">
                 <a:solidFill>
-                  <a:srgbClr val="CC9933"/>
+                  <a:srgbClr val="E8963C"/>
                 </a:solidFill>
                 <a:latin typeface="Arial" pitchFamily="34" charset="0"/>
                 <a:ea typeface="Arial" pitchFamily="34" charset="-122"/>
@@ -15304,7 +15304,7 @@
             <a:r>
               <a:rPr lang="en-US" sz="6000" b="1" dirty="0">
                 <a:solidFill>
-                  <a:srgbClr val="CC9933"/>
+                  <a:srgbClr val="E8963C"/>
                 </a:solidFill>
                 <a:latin typeface="Arial" pitchFamily="34" charset="0"/>
                 <a:ea typeface="Arial" pitchFamily="34" charset="-122"/>
@@ -15409,7 +15409,7 @@
             <a:r>
               <a:rPr lang="en-US" sz="6000" b="1" dirty="0">
                 <a:solidFill>
-                  <a:srgbClr val="CC9933"/>
+                  <a:srgbClr val="E8963C"/>
                 </a:solidFill>
                 <a:latin typeface="Arial" pitchFamily="34" charset="0"/>
                 <a:ea typeface="Arial" pitchFamily="34" charset="-122"/>
@@ -15490,7 +15490,7 @@
             <a:lvl1pPr>
               <a:defRPr sz="900">
                 <a:solidFill>
-                  <a:srgbClr val="CC9933"/>
+                  <a:srgbClr val="E8963C"/>
                 </a:solidFill>
                 <a:latin typeface="Arial"/>
                 <a:ea typeface="Arial"/>
@@ -15560,7 +15560,7 @@
             <a:r>
               <a:rPr lang="en-US" sz="8800" b="1" dirty="0">
                 <a:solidFill>
-                  <a:srgbClr val="CC9933"/>
+                  <a:srgbClr val="E8963C"/>
                 </a:solidFill>
                 <a:latin typeface="Arial" pitchFamily="34" charset="0"/>
                 <a:ea typeface="Arial" pitchFamily="34" charset="-122"/>
@@ -15638,7 +15638,7 @@
             <a:r>
               <a:rPr lang="en-US" sz="1600" i="1" dirty="0">
                 <a:solidFill>
-                  <a:srgbClr val="CC9933"/>
+                  <a:srgbClr val="E8963C"/>
                 </a:solidFill>
                 <a:latin typeface="Arial" pitchFamily="34" charset="0"/>
                 <a:ea typeface="Arial" pitchFamily="34" charset="-122"/>
@@ -15665,11 +15665,11 @@
             <a:avLst/>
           </a:prstGeom>
           <a:solidFill>
-            <a:srgbClr val="CC9933"/>
+            <a:srgbClr val="E8963C"/>
           </a:solidFill>
           <a:ln w="12700">
             <a:solidFill>
-              <a:srgbClr val="CC9933"/>
+              <a:srgbClr val="E8963C"/>
             </a:solidFill>
             <a:prstDash val="solid"/>
           </a:ln>
@@ -15729,7 +15729,7 @@
             <a:lvl1pPr>
               <a:defRPr sz="900">
                 <a:solidFill>
-                  <a:srgbClr val="CC9933"/>
+                  <a:srgbClr val="E8963C"/>
                 </a:solidFill>
                 <a:latin typeface="Arial"/>
                 <a:ea typeface="Arial"/>
@@ -15799,7 +15799,7 @@
             <a:r>
               <a:rPr lang="en-US" sz="3000" b="1" dirty="0">
                 <a:solidFill>
-                  <a:srgbClr val="CC9933"/>
+                  <a:srgbClr val="E8963C"/>
                 </a:solidFill>
                 <a:latin typeface="Arial" pitchFamily="34" charset="0"/>
                 <a:ea typeface="Arial" pitchFamily="34" charset="-122"/>
@@ -15853,11 +15853,11 @@
             <a:avLst/>
           </a:prstGeom>
           <a:solidFill>
-            <a:srgbClr val="CC9933"/>
+            <a:srgbClr val="E8963C"/>
           </a:solidFill>
           <a:ln w="12700">
             <a:solidFill>
-              <a:srgbClr val="CC9933"/>
+              <a:srgbClr val="E8963C"/>
             </a:solidFill>
             <a:prstDash val="solid"/>
           </a:ln>
@@ -15914,7 +15914,7 @@
             <a:r>
               <a:rPr lang="en-US" sz="1500" b="1" dirty="0">
                 <a:solidFill>
-                  <a:srgbClr val="CC9933"/>
+                  <a:srgbClr val="E8963C"/>
                 </a:solidFill>
                 <a:latin typeface="Arial" pitchFamily="34" charset="0"/>
                 <a:ea typeface="Arial" pitchFamily="34" charset="-122"/>
@@ -16007,11 +16007,11 @@
             <a:avLst/>
           </a:prstGeom>
           <a:solidFill>
-            <a:srgbClr val="CC9933"/>
+            <a:srgbClr val="E8963C"/>
           </a:solidFill>
           <a:ln w="12700">
             <a:solidFill>
-              <a:srgbClr val="CC9933"/>
+              <a:srgbClr val="E8963C"/>
             </a:solidFill>
             <a:prstDash val="solid"/>
           </a:ln>
@@ -16068,7 +16068,7 @@
             <a:r>
               <a:rPr lang="en-US" sz="1500" b="1" dirty="0">
                 <a:solidFill>
-                  <a:srgbClr val="CC9933"/>
+                  <a:srgbClr val="E8963C"/>
                 </a:solidFill>
                 <a:latin typeface="Arial" pitchFamily="34" charset="0"/>
                 <a:ea typeface="Arial" pitchFamily="34" charset="-122"/>
@@ -16161,11 +16161,11 @@
             <a:avLst/>
           </a:prstGeom>
           <a:solidFill>
-            <a:srgbClr val="CC9933"/>
+            <a:srgbClr val="E8963C"/>
           </a:solidFill>
           <a:ln w="12700">
             <a:solidFill>
-              <a:srgbClr val="CC9933"/>
+              <a:srgbClr val="E8963C"/>
             </a:solidFill>
             <a:prstDash val="solid"/>
           </a:ln>
@@ -16222,7 +16222,7 @@
             <a:r>
               <a:rPr lang="en-US" sz="1500" b="1" dirty="0">
                 <a:solidFill>
-                  <a:srgbClr val="CC9933"/>
+                  <a:srgbClr val="E8963C"/>
                 </a:solidFill>
                 <a:latin typeface="Arial" pitchFamily="34" charset="0"/>
                 <a:ea typeface="Arial" pitchFamily="34" charset="-122"/>
@@ -16315,11 +16315,11 @@
             <a:avLst/>
           </a:prstGeom>
           <a:solidFill>
-            <a:srgbClr val="CC9933"/>
+            <a:srgbClr val="E8963C"/>
           </a:solidFill>
           <a:ln w="12700">
             <a:solidFill>
-              <a:srgbClr val="CC9933"/>
+              <a:srgbClr val="E8963C"/>
             </a:solidFill>
             <a:prstDash val="solid"/>
           </a:ln>
@@ -16376,7 +16376,7 @@
             <a:r>
               <a:rPr lang="en-US" sz="1500" b="1" dirty="0">
                 <a:solidFill>
-                  <a:srgbClr val="CC9933"/>
+                  <a:srgbClr val="E8963C"/>
                 </a:solidFill>
                 <a:latin typeface="Arial" pitchFamily="34" charset="0"/>
                 <a:ea typeface="Arial" pitchFamily="34" charset="-122"/>
@@ -16469,11 +16469,11 @@
             <a:avLst/>
           </a:prstGeom>
           <a:solidFill>
-            <a:srgbClr val="CC9933"/>
+            <a:srgbClr val="E8963C"/>
           </a:solidFill>
           <a:ln w="12700">
             <a:solidFill>
-              <a:srgbClr val="CC9933"/>
+              <a:srgbClr val="E8963C"/>
             </a:solidFill>
             <a:prstDash val="solid"/>
           </a:ln>
@@ -16530,7 +16530,7 @@
             <a:r>
               <a:rPr lang="en-US" sz="1500" b="1" dirty="0">
                 <a:solidFill>
-                  <a:srgbClr val="CC9933"/>
+                  <a:srgbClr val="E8963C"/>
                 </a:solidFill>
                 <a:latin typeface="Arial" pitchFamily="34" charset="0"/>
                 <a:ea typeface="Arial" pitchFamily="34" charset="-122"/>
@@ -16623,11 +16623,11 @@
             <a:avLst/>
           </a:prstGeom>
           <a:solidFill>
-            <a:srgbClr val="CC9933"/>
+            <a:srgbClr val="E8963C"/>
           </a:solidFill>
           <a:ln w="12700">
             <a:solidFill>
-              <a:srgbClr val="CC9933"/>
+              <a:srgbClr val="E8963C"/>
             </a:solidFill>
             <a:prstDash val="solid"/>
           </a:ln>
@@ -16684,7 +16684,7 @@
             <a:r>
               <a:rPr lang="en-US" sz="1500" b="1" dirty="0">
                 <a:solidFill>
-                  <a:srgbClr val="CC9933"/>
+                  <a:srgbClr val="E8963C"/>
                 </a:solidFill>
                 <a:latin typeface="Arial" pitchFamily="34" charset="0"/>
                 <a:ea typeface="Arial" pitchFamily="34" charset="-122"/>
@@ -16765,7 +16765,7 @@
             <a:lvl1pPr>
               <a:defRPr sz="900">
                 <a:solidFill>
-                  <a:srgbClr val="CC9933"/>
+                  <a:srgbClr val="E8963C"/>
                 </a:solidFill>
                 <a:latin typeface="Arial"/>
                 <a:ea typeface="Arial"/>
@@ -16835,7 +16835,7 @@
             <a:r>
               <a:rPr lang="en-US" sz="3000" b="1" dirty="0">
                 <a:solidFill>
-                  <a:srgbClr val="CC9933"/>
+                  <a:srgbClr val="E8963C"/>
                 </a:solidFill>
                 <a:latin typeface="Arial" pitchFamily="34" charset="0"/>
                 <a:ea typeface="Arial" pitchFamily="34" charset="-122"/>
@@ -16864,11 +16864,11 @@
             </a:avLst>
           </a:prstGeom>
           <a:solidFill>
-            <a:srgbClr val="CC9933"/>
+            <a:srgbClr val="E8963C"/>
           </a:solidFill>
           <a:ln w="12700">
             <a:solidFill>
-              <a:srgbClr val="CC9933"/>
+              <a:srgbClr val="E8963C"/>
             </a:solidFill>
             <a:prstDash val="solid"/>
           </a:ln>
@@ -16967,7 +16967,7 @@
             <a:r>
               <a:rPr lang="en-US" sz="2000" b="1" dirty="0">
                 <a:solidFill>
-                  <a:srgbClr val="CC9933"/>
+                  <a:srgbClr val="E8963C"/>
                 </a:solidFill>
                 <a:latin typeface="Arial" pitchFamily="34" charset="0"/>
                 <a:ea typeface="Arial" pitchFamily="34" charset="-122"/>
@@ -17072,7 +17072,7 @@
             <a:r>
               <a:rPr lang="en-US" sz="2000" b="1" dirty="0">
                 <a:solidFill>
-                  <a:srgbClr val="CC9933"/>
+                  <a:srgbClr val="E8963C"/>
                 </a:solidFill>
                 <a:latin typeface="Arial" pitchFamily="34" charset="0"/>
                 <a:ea typeface="Arial" pitchFamily="34" charset="-122"/>
@@ -17177,7 +17177,7 @@
             <a:r>
               <a:rPr lang="en-US" sz="2000" b="1" dirty="0">
                 <a:solidFill>
-                  <a:srgbClr val="CC9933"/>
+                  <a:srgbClr val="E8963C"/>
                 </a:solidFill>
                 <a:latin typeface="Arial" pitchFamily="34" charset="0"/>
                 <a:ea typeface="Arial" pitchFamily="34" charset="-122"/>
@@ -17282,7 +17282,7 @@
             <a:r>
               <a:rPr lang="en-US" sz="2000" b="1" dirty="0">
                 <a:solidFill>
-                  <a:srgbClr val="CC9933"/>
+                  <a:srgbClr val="E8963C"/>
                 </a:solidFill>
                 <a:latin typeface="Arial" pitchFamily="34" charset="0"/>
                 <a:ea typeface="Arial" pitchFamily="34" charset="-122"/>
@@ -17387,7 +17387,7 @@
             <a:r>
               <a:rPr lang="en-US" sz="2000" b="1" dirty="0">
                 <a:solidFill>
-                  <a:srgbClr val="CC9933"/>
+                  <a:srgbClr val="E8963C"/>
                 </a:solidFill>
                 <a:latin typeface="Arial" pitchFamily="34" charset="0"/>
                 <a:ea typeface="Arial" pitchFamily="34" charset="-122"/>
@@ -17492,7 +17492,7 @@
             <a:r>
               <a:rPr lang="en-US" sz="2000" b="1" dirty="0">
                 <a:solidFill>
-                  <a:srgbClr val="CC9933"/>
+                  <a:srgbClr val="E8963C"/>
                 </a:solidFill>
                 <a:latin typeface="Arial" pitchFamily="34" charset="0"/>
                 <a:ea typeface="Arial" pitchFamily="34" charset="-122"/>
@@ -17597,7 +17597,7 @@
             <a:r>
               <a:rPr lang="en-US" sz="2000" b="1" dirty="0">
                 <a:solidFill>
-                  <a:srgbClr val="CC9933"/>
+                  <a:srgbClr val="E8963C"/>
                 </a:solidFill>
                 <a:latin typeface="Arial" pitchFamily="34" charset="0"/>
                 <a:ea typeface="Arial" pitchFamily="34" charset="-122"/>
@@ -17675,7 +17675,7 @@
             <a:r>
               <a:rPr lang="en-US" sz="1300" i="1" dirty="0">
                 <a:solidFill>
-                  <a:srgbClr val="CC9933"/>
+                  <a:srgbClr val="E8963C"/>
                 </a:solidFill>
                 <a:latin typeface="Arial" pitchFamily="34" charset="0"/>
                 <a:ea typeface="Arial" pitchFamily="34" charset="-122"/>
@@ -17708,7 +17708,7 @@
           </a:solidFill>
           <a:ln w="15875">
             <a:solidFill>
-              <a:srgbClr val="CC9933"/>
+              <a:srgbClr val="E8963C"/>
             </a:solidFill>
             <a:prstDash val="solid"/>
           </a:ln>
@@ -17741,7 +17741,7 @@
             <a:r>
               <a:rPr lang="en-US" sz="1500" b="1" dirty="0">
                 <a:solidFill>
-                  <a:srgbClr val="CC9933"/>
+                  <a:srgbClr val="E8963C"/>
                 </a:solidFill>
                 <a:latin typeface="Arial" pitchFamily="34" charset="0"/>
                 <a:ea typeface="Arial" pitchFamily="34" charset="-122"/>
@@ -17797,7 +17797,7 @@
             <a:lvl1pPr>
               <a:defRPr sz="900">
                 <a:solidFill>
-                  <a:srgbClr val="CC9933"/>
+                  <a:srgbClr val="E8963C"/>
                 </a:solidFill>
                 <a:latin typeface="Arial"/>
                 <a:ea typeface="Arial"/>
@@ -17867,7 +17867,7 @@
             <a:r>
               <a:rPr lang="en-US" sz="3000" b="1" dirty="0">
                 <a:solidFill>
-                  <a:srgbClr val="CC9933"/>
+                  <a:srgbClr val="E8963C"/>
                 </a:solidFill>
                 <a:latin typeface="Arial" pitchFamily="34" charset="0"/>
                 <a:ea typeface="Arial" pitchFamily="34" charset="-122"/>
@@ -17921,11 +17921,11 @@
             <a:avLst/>
           </a:prstGeom>
           <a:solidFill>
-            <a:srgbClr val="CC9933"/>
+            <a:srgbClr val="E8963C"/>
           </a:solidFill>
           <a:ln w="12700">
             <a:solidFill>
-              <a:srgbClr val="CC9933"/>
+              <a:srgbClr val="E8963C"/>
             </a:solidFill>
             <a:prstDash val="solid"/>
           </a:ln>
@@ -17997,7 +17997,7 @@
             <a:r>
               <a:rPr lang="en-US" sz="1600" b="1" dirty="0">
                 <a:solidFill>
-                  <a:srgbClr val="CC9933"/>
+                  <a:srgbClr val="E8963C"/>
                 </a:solidFill>
                 <a:latin typeface="Arial" pitchFamily="34" charset="0"/>
                 <a:ea typeface="Arial" pitchFamily="34" charset="-122"/>
@@ -18090,11 +18090,11 @@
             <a:avLst/>
           </a:prstGeom>
           <a:solidFill>
-            <a:srgbClr val="CC9933"/>
+            <a:srgbClr val="E8963C"/>
           </a:solidFill>
           <a:ln w="12700">
             <a:solidFill>
-              <a:srgbClr val="CC9933"/>
+              <a:srgbClr val="E8963C"/>
             </a:solidFill>
             <a:prstDash val="solid"/>
           </a:ln>
@@ -18166,7 +18166,7 @@
             <a:r>
               <a:rPr lang="en-US" sz="1600" b="1" dirty="0">
                 <a:solidFill>
-                  <a:srgbClr val="CC9933"/>
+                  <a:srgbClr val="E8963C"/>
                 </a:solidFill>
                 <a:latin typeface="Arial" pitchFamily="34" charset="0"/>
                 <a:ea typeface="Arial" pitchFamily="34" charset="-122"/>
@@ -18259,11 +18259,11 @@
             <a:avLst/>
           </a:prstGeom>
           <a:solidFill>
-            <a:srgbClr val="CC9933"/>
+            <a:srgbClr val="E8963C"/>
           </a:solidFill>
           <a:ln w="12700">
             <a:solidFill>
-              <a:srgbClr val="CC9933"/>
+              <a:srgbClr val="E8963C"/>
             </a:solidFill>
             <a:prstDash val="solid"/>
           </a:ln>
@@ -18335,7 +18335,7 @@
             <a:r>
               <a:rPr lang="en-US" sz="1600" b="1" dirty="0">
                 <a:solidFill>
-                  <a:srgbClr val="CC9933"/>
+                  <a:srgbClr val="E8963C"/>
                 </a:solidFill>
                 <a:latin typeface="Arial" pitchFamily="34" charset="0"/>
                 <a:ea typeface="Arial" pitchFamily="34" charset="-122"/>
@@ -18428,11 +18428,11 @@
             <a:avLst/>
           </a:prstGeom>
           <a:solidFill>
-            <a:srgbClr val="CC9933"/>
+            <a:srgbClr val="E8963C"/>
           </a:solidFill>
           <a:ln w="12700">
             <a:solidFill>
-              <a:srgbClr val="CC9933"/>
+              <a:srgbClr val="E8963C"/>
             </a:solidFill>
             <a:prstDash val="solid"/>
           </a:ln>
@@ -18504,7 +18504,7 @@
             <a:r>
               <a:rPr lang="en-US" sz="1600" b="1" dirty="0">
                 <a:solidFill>
-                  <a:srgbClr val="CC9933"/>
+                  <a:srgbClr val="E8963C"/>
                 </a:solidFill>
                 <a:latin typeface="Arial" pitchFamily="34" charset="0"/>
                 <a:ea typeface="Arial" pitchFamily="34" charset="-122"/>
@@ -18585,7 +18585,7 @@
             <a:lvl1pPr>
               <a:defRPr sz="900">
                 <a:solidFill>
-                  <a:srgbClr val="CC9933"/>
+                  <a:srgbClr val="E8963C"/>
                 </a:solidFill>
                 <a:latin typeface="Arial"/>
                 <a:ea typeface="Arial"/>
@@ -18655,7 +18655,7 @@
             <a:r>
               <a:rPr lang="en-US" sz="3000" b="1" dirty="0">
                 <a:solidFill>
-                  <a:srgbClr val="CC9933"/>
+                  <a:srgbClr val="E8963C"/>
                 </a:solidFill>
                 <a:latin typeface="Arial" pitchFamily="34" charset="0"/>
                 <a:ea typeface="Arial" pitchFamily="34" charset="-122"/>
@@ -18682,11 +18682,11 @@
             <a:avLst/>
           </a:prstGeom>
           <a:solidFill>
-            <a:srgbClr val="CC9933"/>
+            <a:srgbClr val="E8963C"/>
           </a:solidFill>
           <a:ln w="12700">
             <a:solidFill>
-              <a:srgbClr val="CC9933"/>
+              <a:srgbClr val="E8963C"/>
             </a:solidFill>
             <a:prstDash val="solid"/>
           </a:ln>
@@ -18782,7 +18782,7 @@
             <a:r>
               <a:rPr lang="en-US" sz="1250" dirty="0">
                 <a:solidFill>
-                  <a:srgbClr val="CC9933"/>
+                  <a:srgbClr val="E8963C"/>
                 </a:solidFill>
                 <a:latin typeface="Arial" pitchFamily="34" charset="0"/>
                 <a:ea typeface="Arial" pitchFamily="34" charset="-122"/>
@@ -18809,11 +18809,11 @@
             <a:avLst/>
           </a:prstGeom>
           <a:solidFill>
-            <a:srgbClr val="CC9933"/>
+            <a:srgbClr val="E8963C"/>
           </a:solidFill>
           <a:ln w="12700">
             <a:solidFill>
-              <a:srgbClr val="CC9933"/>
+              <a:srgbClr val="E8963C"/>
             </a:solidFill>
             <a:prstDash val="solid"/>
           </a:ln>
@@ -18909,7 +18909,7 @@
             <a:r>
               <a:rPr lang="en-US" sz="1250" dirty="0">
                 <a:solidFill>
-                  <a:srgbClr val="CC9933"/>
+                  <a:srgbClr val="E8963C"/>
                 </a:solidFill>
                 <a:latin typeface="Arial" pitchFamily="34" charset="0"/>
                 <a:ea typeface="Arial" pitchFamily="34" charset="-122"/>
@@ -18936,11 +18936,11 @@
             <a:avLst/>
           </a:prstGeom>
           <a:solidFill>
-            <a:srgbClr val="CC9933"/>
+            <a:srgbClr val="E8963C"/>
           </a:solidFill>
           <a:ln w="12700">
             <a:solidFill>
-              <a:srgbClr val="CC9933"/>
+              <a:srgbClr val="E8963C"/>
             </a:solidFill>
             <a:prstDash val="solid"/>
           </a:ln>
@@ -19036,7 +19036,7 @@
             <a:r>
               <a:rPr lang="en-US" sz="1250" dirty="0">
                 <a:solidFill>
-                  <a:srgbClr val="CC9933"/>
+                  <a:srgbClr val="E8963C"/>
                 </a:solidFill>
                 <a:latin typeface="Arial" pitchFamily="34" charset="0"/>
                 <a:ea typeface="Arial" pitchFamily="34" charset="-122"/>
@@ -19069,7 +19069,7 @@
           </a:solidFill>
           <a:ln w="15875">
             <a:solidFill>
-              <a:srgbClr val="CC9933"/>
+              <a:srgbClr val="E8963C"/>
             </a:solidFill>
             <a:prstDash val="solid"/>
           </a:ln>
@@ -19090,11 +19090,11 @@
             <a:avLst/>
           </a:prstGeom>
           <a:solidFill>
-            <a:srgbClr val="CC9933"/>
+            <a:srgbClr val="E8963C"/>
           </a:solidFill>
           <a:ln w="12700">
             <a:solidFill>
-              <a:srgbClr val="CC9933"/>
+              <a:srgbClr val="E8963C"/>
             </a:solidFill>
             <a:prstDash val="solid"/>
           </a:ln>
@@ -19151,7 +19151,7 @@
             <a:r>
               <a:rPr lang="en-US" sz="1700" b="1" dirty="0">
                 <a:solidFill>
-                  <a:srgbClr val="CC9933"/>
+                  <a:srgbClr val="E8963C"/>
                 </a:solidFill>
                 <a:latin typeface="Arial" pitchFamily="34" charset="0"/>
                 <a:ea typeface="Arial" pitchFamily="34" charset="-122"/>
@@ -19229,7 +19229,7 @@
             <a:r>
               <a:rPr lang="en-US" sz="3000" b="1" dirty="0">
                 <a:solidFill>
-                  <a:srgbClr val="CC9933"/>
+                  <a:srgbClr val="E8963C"/>
                 </a:solidFill>
                 <a:latin typeface="Arial" pitchFamily="34" charset="0"/>
                 <a:ea typeface="Arial" pitchFamily="34" charset="-122"/>
@@ -19271,7 +19271,7 @@
             <a:lvl1pPr>
               <a:defRPr sz="900">
                 <a:solidFill>
-                  <a:srgbClr val="CC9933"/>
+                  <a:srgbClr val="E8963C"/>
                 </a:solidFill>
                 <a:latin typeface="Arial"/>
                 <a:ea typeface="Arial"/>
@@ -19341,7 +19341,7 @@
             <a:r>
               <a:rPr lang="en-US" sz="3000" b="1" dirty="0">
                 <a:solidFill>
-                  <a:srgbClr val="CC9933"/>
+                  <a:srgbClr val="E8963C"/>
                 </a:solidFill>
                 <a:latin typeface="Arial" pitchFamily="34" charset="0"/>
                 <a:ea typeface="Arial" pitchFamily="34" charset="-122"/>
@@ -19370,11 +19370,11 @@
             </a:avLst>
           </a:prstGeom>
           <a:solidFill>
-            <a:srgbClr val="CC9933"/>
+            <a:srgbClr val="E8963C"/>
           </a:solidFill>
           <a:ln w="12700">
             <a:solidFill>
-              <a:srgbClr val="CC9933"/>
+              <a:srgbClr val="E8963C"/>
             </a:solidFill>
             <a:prstDash val="solid"/>
           </a:ln>
@@ -19477,7 +19477,7 @@
           </a:solidFill>
           <a:ln w="12700">
             <a:solidFill>
-              <a:srgbClr val="CC9933"/>
+              <a:srgbClr val="E8963C"/>
             </a:solidFill>
             <a:prstDash val="solid"/>
           </a:ln>
@@ -19541,7 +19541,7 @@
           </a:solidFill>
           <a:ln w="12700">
             <a:solidFill>
-              <a:srgbClr val="CC9933"/>
+              <a:srgbClr val="E8963C"/>
             </a:solidFill>
             <a:prstDash val="solid"/>
           </a:ln>
@@ -19605,7 +19605,7 @@
           </a:solidFill>
           <a:ln w="12700">
             <a:solidFill>
-              <a:srgbClr val="CC9933"/>
+              <a:srgbClr val="E8963C"/>
             </a:solidFill>
             <a:prstDash val="solid"/>
           </a:ln>
@@ -19669,7 +19669,7 @@
           </a:solidFill>
           <a:ln w="12700">
             <a:solidFill>
-              <a:srgbClr val="CC9933"/>
+              <a:srgbClr val="E8963C"/>
             </a:solidFill>
             <a:prstDash val="solid"/>
           </a:ln>
@@ -19733,7 +19733,7 @@
           </a:solidFill>
           <a:ln w="12700">
             <a:solidFill>
-              <a:srgbClr val="CC9933"/>
+              <a:srgbClr val="E8963C"/>
             </a:solidFill>
             <a:prstDash val="solid"/>
           </a:ln>
@@ -19797,7 +19797,7 @@
           </a:solidFill>
           <a:ln w="12700">
             <a:solidFill>
-              <a:srgbClr val="CC9933"/>
+              <a:srgbClr val="E8963C"/>
             </a:solidFill>
             <a:prstDash val="solid"/>
           </a:ln>
@@ -19861,7 +19861,7 @@
           </a:solidFill>
           <a:ln w="12700">
             <a:solidFill>
-              <a:srgbClr val="CC9933"/>
+              <a:srgbClr val="E8963C"/>
             </a:solidFill>
             <a:prstDash val="solid"/>
           </a:ln>
@@ -19921,11 +19921,11 @@
             <a:avLst/>
           </a:prstGeom>
           <a:solidFill>
-            <a:srgbClr val="CC9933"/>
+            <a:srgbClr val="E8963C"/>
           </a:solidFill>
           <a:ln w="12700">
             <a:solidFill>
-              <a:srgbClr val="CC9933"/>
+              <a:srgbClr val="E8963C"/>
             </a:solidFill>
             <a:prstDash val="solid"/>
           </a:ln>
@@ -19985,11 +19985,11 @@
             <a:avLst/>
           </a:prstGeom>
           <a:solidFill>
-            <a:srgbClr val="CC9933"/>
+            <a:srgbClr val="E8963C"/>
           </a:solidFill>
           <a:ln w="12700">
             <a:solidFill>
-              <a:srgbClr val="CC9933"/>
+              <a:srgbClr val="E8963C"/>
             </a:solidFill>
             <a:prstDash val="solid"/>
           </a:ln>
@@ -20049,11 +20049,11 @@
             <a:avLst/>
           </a:prstGeom>
           <a:solidFill>
-            <a:srgbClr val="CC9933"/>
+            <a:srgbClr val="E8963C"/>
           </a:solidFill>
           <a:ln w="12700">
             <a:solidFill>
-              <a:srgbClr val="CC9933"/>
+              <a:srgbClr val="E8963C"/>
             </a:solidFill>
             <a:prstDash val="solid"/>
           </a:ln>
@@ -20125,7 +20125,7 @@
             <a:r>
               <a:rPr lang="en-US" sz="1200" dirty="0">
                 <a:solidFill>
-                  <a:srgbClr val="CC9933"/>
+                  <a:srgbClr val="E8963C"/>
                 </a:solidFill>
                 <a:latin typeface="Arial" pitchFamily="34" charset="0"/>
                 <a:ea typeface="Arial" pitchFamily="34" charset="-122"/>
@@ -20164,7 +20164,7 @@
             <a:r>
               <a:rPr lang="en-US" sz="1200" dirty="0">
                 <a:solidFill>
-                  <a:srgbClr val="CC9933"/>
+                  <a:srgbClr val="E8963C"/>
                 </a:solidFill>
                 <a:latin typeface="Arial" pitchFamily="34" charset="0"/>
                 <a:ea typeface="Arial" pitchFamily="34" charset="-122"/>
@@ -20197,7 +20197,7 @@
           </a:solidFill>
           <a:ln w="15875">
             <a:solidFill>
-              <a:srgbClr val="CC9933"/>
+              <a:srgbClr val="E8963C"/>
             </a:solidFill>
             <a:prstDash val="solid"/>
           </a:ln>
@@ -20272,7 +20272,7 @@
             <a:lvl1pPr>
               <a:defRPr sz="900">
                 <a:solidFill>
-                  <a:srgbClr val="CC9933"/>
+                  <a:srgbClr val="E8963C"/>
                 </a:solidFill>
                 <a:latin typeface="Arial"/>
                 <a:ea typeface="Arial"/>
@@ -20342,7 +20342,7 @@
             <a:r>
               <a:rPr lang="en-US" sz="8800" b="1" dirty="0">
                 <a:solidFill>
-                  <a:srgbClr val="CC9933"/>
+                  <a:srgbClr val="E8963C"/>
                 </a:solidFill>
                 <a:latin typeface="Arial" pitchFamily="34" charset="0"/>
                 <a:ea typeface="Arial" pitchFamily="34" charset="-122"/>
@@ -20420,7 +20420,7 @@
             <a:r>
               <a:rPr lang="en-US" sz="1600" i="1" dirty="0">
                 <a:solidFill>
-                  <a:srgbClr val="CC9933"/>
+                  <a:srgbClr val="E8963C"/>
                 </a:solidFill>
                 <a:latin typeface="Arial" pitchFamily="34" charset="0"/>
                 <a:ea typeface="Arial" pitchFamily="34" charset="-122"/>
@@ -20447,11 +20447,11 @@
             <a:avLst/>
           </a:prstGeom>
           <a:solidFill>
-            <a:srgbClr val="CC9933"/>
+            <a:srgbClr val="E8963C"/>
           </a:solidFill>
           <a:ln w="12700">
             <a:solidFill>
-              <a:srgbClr val="CC9933"/>
+              <a:srgbClr val="E8963C"/>
             </a:solidFill>
             <a:prstDash val="solid"/>
           </a:ln>
@@ -20511,7 +20511,7 @@
             <a:lvl1pPr>
               <a:defRPr sz="900">
                 <a:solidFill>
-                  <a:srgbClr val="CC9933"/>
+                  <a:srgbClr val="E8963C"/>
                 </a:solidFill>
                 <a:latin typeface="Arial"/>
                 <a:ea typeface="Arial"/>
@@ -20581,7 +20581,7 @@
             <a:r>
               <a:rPr lang="en-US" sz="3000" b="1" dirty="0">
                 <a:solidFill>
-                  <a:srgbClr val="CC9933"/>
+                  <a:srgbClr val="E8963C"/>
                 </a:solidFill>
                 <a:latin typeface="Arial" pitchFamily="34" charset="0"/>
                 <a:ea typeface="Arial" pitchFamily="34" charset="-122"/>
@@ -20759,7 +20759,7 @@
           </a:solidFill>
           <a:ln w="15875">
             <a:solidFill>
-              <a:srgbClr val="CC9933"/>
+              <a:srgbClr val="E8963C"/>
             </a:solidFill>
             <a:prstDash val="solid"/>
           </a:ln>
@@ -20831,7 +20831,7 @@
             <a:r>
               <a:rPr lang="en-US" sz="2200" b="1" dirty="0">
                 <a:solidFill>
-                  <a:srgbClr val="CC9933"/>
+                  <a:srgbClr val="E8963C"/>
                 </a:solidFill>
                 <a:latin typeface="Arial" pitchFamily="34" charset="0"/>
                 <a:ea typeface="Arial" pitchFamily="34" charset="-122"/>
@@ -20870,7 +20870,7 @@
             <a:r>
               <a:rPr lang="en-US" sz="1600" i="1" dirty="0">
                 <a:solidFill>
-                  <a:srgbClr val="CC9933"/>
+                  <a:srgbClr val="E8963C"/>
                 </a:solidFill>
                 <a:latin typeface="Arial" pitchFamily="34" charset="0"/>
                 <a:ea typeface="Arial" pitchFamily="34" charset="-122"/>
@@ -20951,7 +20951,7 @@
             <a:lvl1pPr>
               <a:defRPr sz="900">
                 <a:solidFill>
-                  <a:srgbClr val="CC9933"/>
+                  <a:srgbClr val="E8963C"/>
                 </a:solidFill>
                 <a:latin typeface="Arial"/>
                 <a:ea typeface="Arial"/>
@@ -21021,7 +21021,7 @@
             <a:r>
               <a:rPr lang="en-US" sz="3000" b="1" dirty="0">
                 <a:solidFill>
-                  <a:srgbClr val="CC9933"/>
+                  <a:srgbClr val="E8963C"/>
                 </a:solidFill>
                 <a:latin typeface="Arial" pitchFamily="34" charset="0"/>
                 <a:ea typeface="Arial" pitchFamily="34" charset="-122"/>
@@ -21081,7 +21081,7 @@
           </a:solidFill>
           <a:ln w="15875">
             <a:solidFill>
-              <a:srgbClr val="CC9933"/>
+              <a:srgbClr val="E8963C"/>
             </a:solidFill>
             <a:prstDash val="solid"/>
           </a:ln>
@@ -21153,7 +21153,7 @@
             <a:r>
               <a:rPr lang="en-US" sz="1600" b="1" dirty="0">
                 <a:solidFill>
-                  <a:srgbClr val="CC9933"/>
+                  <a:srgbClr val="E8963C"/>
                 </a:solidFill>
                 <a:latin typeface="Arial" pitchFamily="34" charset="0"/>
                 <a:ea typeface="Arial" pitchFamily="34" charset="-122"/>
@@ -21192,7 +21192,7 @@
             <a:r>
               <a:rPr lang="en-US" sz="1300" b="1" dirty="0">
                 <a:solidFill>
-                  <a:srgbClr val="CC9933"/>
+                  <a:srgbClr val="E8963C"/>
                 </a:solidFill>
                 <a:latin typeface="Arial" pitchFamily="34" charset="0"/>
                 <a:ea typeface="Arial" pitchFamily="34" charset="-122"/>
@@ -21309,7 +21309,7 @@
             <a:r>
               <a:rPr lang="en-US" sz="1300" b="1" dirty="0">
                 <a:solidFill>
-                  <a:srgbClr val="CC9933"/>
+                  <a:srgbClr val="E8963C"/>
                 </a:solidFill>
                 <a:latin typeface="Arial" pitchFamily="34" charset="0"/>
                 <a:ea typeface="Arial" pitchFamily="34" charset="-122"/>
@@ -21426,7 +21426,7 @@
             <a:r>
               <a:rPr lang="en-US" sz="1300" b="1" dirty="0">
                 <a:solidFill>
-                  <a:srgbClr val="CC9933"/>
+                  <a:srgbClr val="E8963C"/>
                 </a:solidFill>
                 <a:latin typeface="Arial" pitchFamily="34" charset="0"/>
                 <a:ea typeface="Arial" pitchFamily="34" charset="-122"/>
@@ -21543,7 +21543,7 @@
             <a:r>
               <a:rPr lang="en-US" sz="1300" b="1" dirty="0">
                 <a:solidFill>
-                  <a:srgbClr val="CC9933"/>
+                  <a:srgbClr val="E8963C"/>
                 </a:solidFill>
                 <a:latin typeface="Arial" pitchFamily="34" charset="0"/>
                 <a:ea typeface="Arial" pitchFamily="34" charset="-122"/>
@@ -21660,7 +21660,7 @@
             <a:r>
               <a:rPr lang="en-US" sz="1300" b="1" dirty="0">
                 <a:solidFill>
-                  <a:srgbClr val="CC9933"/>
+                  <a:srgbClr val="E8963C"/>
                 </a:solidFill>
                 <a:latin typeface="Arial" pitchFamily="34" charset="0"/>
                 <a:ea typeface="Arial" pitchFamily="34" charset="-122"/>
@@ -21780,7 +21780,7 @@
             <a:lvl1pPr>
               <a:defRPr sz="900">
                 <a:solidFill>
-                  <a:srgbClr val="CC9933"/>
+                  <a:srgbClr val="E8963C"/>
                 </a:solidFill>
                 <a:latin typeface="Arial"/>
                 <a:ea typeface="Arial"/>
@@ -21850,7 +21850,7 @@
             <a:r>
               <a:rPr lang="en-US" sz="3000" b="1" dirty="0">
                 <a:solidFill>
-                  <a:srgbClr val="CC9933"/>
+                  <a:srgbClr val="E8963C"/>
                 </a:solidFill>
                 <a:latin typeface="Arial" pitchFamily="34" charset="0"/>
                 <a:ea typeface="Arial" pitchFamily="34" charset="-122"/>
@@ -21889,7 +21889,7 @@
             <a:r>
               <a:rPr lang="en-US" sz="1600" i="1" dirty="0">
                 <a:solidFill>
-                  <a:srgbClr val="CC9933"/>
+                  <a:srgbClr val="E8963C"/>
                 </a:solidFill>
                 <a:latin typeface="Arial" pitchFamily="34" charset="0"/>
                 <a:ea typeface="Arial" pitchFamily="34" charset="-122"/>
@@ -21943,11 +21943,11 @@
             <a:avLst/>
           </a:prstGeom>
           <a:solidFill>
-            <a:srgbClr val="CC9933"/>
+            <a:srgbClr val="E8963C"/>
           </a:solidFill>
           <a:ln w="12700">
             <a:solidFill>
-              <a:srgbClr val="CC9933"/>
+              <a:srgbClr val="E8963C"/>
             </a:solidFill>
             <a:prstDash val="solid"/>
           </a:ln>
@@ -22004,7 +22004,7 @@
             <a:r>
               <a:rPr lang="en-US" sz="1700" b="1" dirty="0">
                 <a:solidFill>
-                  <a:srgbClr val="CC9933"/>
+                  <a:srgbClr val="E8963C"/>
                 </a:solidFill>
                 <a:latin typeface="Arial" pitchFamily="34" charset="0"/>
                 <a:ea typeface="Arial" pitchFamily="34" charset="-122"/>
@@ -22097,11 +22097,11 @@
             <a:avLst/>
           </a:prstGeom>
           <a:solidFill>
-            <a:srgbClr val="CC9933"/>
+            <a:srgbClr val="E8963C"/>
           </a:solidFill>
           <a:ln w="12700">
             <a:solidFill>
-              <a:srgbClr val="CC9933"/>
+              <a:srgbClr val="E8963C"/>
             </a:solidFill>
             <a:prstDash val="solid"/>
           </a:ln>
@@ -22158,7 +22158,7 @@
             <a:r>
               <a:rPr lang="en-US" sz="1700" b="1" dirty="0">
                 <a:solidFill>
-                  <a:srgbClr val="CC9933"/>
+                  <a:srgbClr val="E8963C"/>
                 </a:solidFill>
                 <a:latin typeface="Arial" pitchFamily="34" charset="0"/>
                 <a:ea typeface="Arial" pitchFamily="34" charset="-122"/>
@@ -22251,11 +22251,11 @@
             <a:avLst/>
           </a:prstGeom>
           <a:solidFill>
-            <a:srgbClr val="CC9933"/>
+            <a:srgbClr val="E8963C"/>
           </a:solidFill>
           <a:ln w="12700">
             <a:solidFill>
-              <a:srgbClr val="CC9933"/>
+              <a:srgbClr val="E8963C"/>
             </a:solidFill>
             <a:prstDash val="solid"/>
           </a:ln>
@@ -22312,7 +22312,7 @@
             <a:r>
               <a:rPr lang="en-US" sz="1700" b="1" dirty="0">
                 <a:solidFill>
-                  <a:srgbClr val="CC9933"/>
+                  <a:srgbClr val="E8963C"/>
                 </a:solidFill>
                 <a:latin typeface="Arial" pitchFamily="34" charset="0"/>
                 <a:ea typeface="Arial" pitchFamily="34" charset="-122"/>
@@ -22393,7 +22393,7 @@
             <a:lvl1pPr>
               <a:defRPr sz="900">
                 <a:solidFill>
-                  <a:srgbClr val="CC9933"/>
+                  <a:srgbClr val="E8963C"/>
                 </a:solidFill>
                 <a:latin typeface="Arial"/>
                 <a:ea typeface="Arial"/>
@@ -22463,7 +22463,7 @@
             <a:r>
               <a:rPr lang="en-US" sz="3000" b="1" dirty="0">
                 <a:solidFill>
-                  <a:srgbClr val="CC9933"/>
+                  <a:srgbClr val="E8963C"/>
                 </a:solidFill>
                 <a:latin typeface="Arial" pitchFamily="34" charset="0"/>
                 <a:ea typeface="Arial" pitchFamily="34" charset="-122"/>
@@ -22556,11 +22556,11 @@
             <a:avLst/>
           </a:prstGeom>
           <a:solidFill>
-            <a:srgbClr val="CC9933"/>
+            <a:srgbClr val="E8963C"/>
           </a:solidFill>
           <a:ln w="12700">
             <a:solidFill>
-              <a:srgbClr val="CC9933"/>
+              <a:srgbClr val="E8963C"/>
             </a:solidFill>
             <a:prstDash val="solid"/>
           </a:ln>
@@ -22617,7 +22617,7 @@
             <a:r>
               <a:rPr lang="en-US" sz="1600" b="1" dirty="0">
                 <a:solidFill>
-                  <a:srgbClr val="CC9933"/>
+                  <a:srgbClr val="E8963C"/>
                 </a:solidFill>
                 <a:latin typeface="Arial" pitchFamily="34" charset="0"/>
                 <a:ea typeface="Arial" pitchFamily="34" charset="-122"/>
@@ -22724,11 +22724,11 @@
             <a:avLst/>
           </a:prstGeom>
           <a:solidFill>
-            <a:srgbClr val="CC9933"/>
+            <a:srgbClr val="E8963C"/>
           </a:solidFill>
           <a:ln w="12700">
             <a:solidFill>
-              <a:srgbClr val="CC9933"/>
+              <a:srgbClr val="E8963C"/>
             </a:solidFill>
             <a:prstDash val="solid"/>
           </a:ln>
@@ -22785,7 +22785,7 @@
             <a:r>
               <a:rPr lang="en-US" sz="1600" b="1" dirty="0">
                 <a:solidFill>
-                  <a:srgbClr val="CC9933"/>
+                  <a:srgbClr val="E8963C"/>
                 </a:solidFill>
                 <a:latin typeface="Arial" pitchFamily="34" charset="0"/>
                 <a:ea typeface="Arial" pitchFamily="34" charset="-122"/>
@@ -22892,11 +22892,11 @@
             <a:avLst/>
           </a:prstGeom>
           <a:solidFill>
-            <a:srgbClr val="CC9933"/>
+            <a:srgbClr val="E8963C"/>
           </a:solidFill>
           <a:ln w="12700">
             <a:solidFill>
-              <a:srgbClr val="CC9933"/>
+              <a:srgbClr val="E8963C"/>
             </a:solidFill>
             <a:prstDash val="solid"/>
           </a:ln>
@@ -22953,7 +22953,7 @@
             <a:r>
               <a:rPr lang="en-US" sz="1600" b="1" dirty="0">
                 <a:solidFill>
-                  <a:srgbClr val="CC9933"/>
+                  <a:srgbClr val="E8963C"/>
                 </a:solidFill>
                 <a:latin typeface="Arial" pitchFamily="34" charset="0"/>
                 <a:ea typeface="Arial" pitchFamily="34" charset="-122"/>
@@ -23060,11 +23060,11 @@
             <a:avLst/>
           </a:prstGeom>
           <a:solidFill>
-            <a:srgbClr val="CC9933"/>
+            <a:srgbClr val="E8963C"/>
           </a:solidFill>
           <a:ln w="12700">
             <a:solidFill>
-              <a:srgbClr val="CC9933"/>
+              <a:srgbClr val="E8963C"/>
             </a:solidFill>
             <a:prstDash val="solid"/>
           </a:ln>
@@ -23121,7 +23121,7 @@
             <a:r>
               <a:rPr lang="en-US" sz="1600" b="1" dirty="0">
                 <a:solidFill>
-                  <a:srgbClr val="CC9933"/>
+                  <a:srgbClr val="E8963C"/>
                 </a:solidFill>
                 <a:latin typeface="Arial" pitchFamily="34" charset="0"/>
                 <a:ea typeface="Arial" pitchFamily="34" charset="-122"/>
@@ -23216,7 +23216,7 @@
             <a:lvl1pPr>
               <a:defRPr sz="900">
                 <a:solidFill>
-                  <a:srgbClr val="CC9933"/>
+                  <a:srgbClr val="E8963C"/>
                 </a:solidFill>
                 <a:latin typeface="Arial"/>
                 <a:ea typeface="Arial"/>

</xml_diff>